<commit_message>
adding plagiarism free file and updated ppt
</commit_message>
<xml_diff>
--- a/COOP2_PPT.pptx
+++ b/COOP2_PPT.pptx
@@ -5,27 +5,32 @@
     <p:sldMasterId id="2147483648" r:id="rId4"/>
   </p:sldMasterIdLst>
   <p:notesMasterIdLst>
-    <p:notesMasterId r:id="rId20"/>
+    <p:notesMasterId r:id="rId25"/>
   </p:notesMasterIdLst>
   <p:handoutMasterIdLst>
-    <p:handoutMasterId r:id="rId21"/>
+    <p:handoutMasterId r:id="rId26"/>
   </p:handoutMasterIdLst>
   <p:sldIdLst>
     <p:sldId id="256" r:id="rId5"/>
     <p:sldId id="257" r:id="rId6"/>
     <p:sldId id="271" r:id="rId7"/>
-    <p:sldId id="269" r:id="rId8"/>
-    <p:sldId id="270" r:id="rId9"/>
-    <p:sldId id="272" r:id="rId10"/>
-    <p:sldId id="273" r:id="rId11"/>
-    <p:sldId id="274" r:id="rId12"/>
-    <p:sldId id="275" r:id="rId13"/>
-    <p:sldId id="276" r:id="rId14"/>
-    <p:sldId id="277" r:id="rId15"/>
-    <p:sldId id="278" r:id="rId16"/>
-    <p:sldId id="279" r:id="rId17"/>
-    <p:sldId id="280" r:id="rId18"/>
-    <p:sldId id="268" r:id="rId19"/>
+    <p:sldId id="281" r:id="rId8"/>
+    <p:sldId id="269" r:id="rId9"/>
+    <p:sldId id="282" r:id="rId10"/>
+    <p:sldId id="270" r:id="rId11"/>
+    <p:sldId id="272" r:id="rId12"/>
+    <p:sldId id="273" r:id="rId13"/>
+    <p:sldId id="274" r:id="rId14"/>
+    <p:sldId id="283" r:id="rId15"/>
+    <p:sldId id="275" r:id="rId16"/>
+    <p:sldId id="284" r:id="rId17"/>
+    <p:sldId id="276" r:id="rId18"/>
+    <p:sldId id="277" r:id="rId19"/>
+    <p:sldId id="278" r:id="rId20"/>
+    <p:sldId id="279" r:id="rId21"/>
+    <p:sldId id="285" r:id="rId22"/>
+    <p:sldId id="280" r:id="rId23"/>
+    <p:sldId id="268" r:id="rId24"/>
   </p:sldIdLst>
   <p:sldSz cx="9144000" cy="6858000" type="screen4x3"/>
   <p:notesSz cx="7559675" cy="10691813"/>
@@ -238,7 +243,7 @@
             <a:fld id="{25D2B5EB-424D-4C39-A8AB-65F1D7895EF3}" type="datetimeFigureOut">
               <a:rPr lang="en-US" smtClean="0"/>
               <a:pPr/>
-              <a:t>5/1/2026</a:t>
+              <a:t>5/19/2026</a:t>
             </a:fld>
             <a:endParaRPr lang="en-US"/>
           </a:p>
@@ -421,7 +426,7 @@
             <a:fld id="{888BC1CF-45D5-4DEE-AAB8-8C5341844FC9}" type="datetimeFigureOut">
               <a:rPr lang="en-US" smtClean="0"/>
               <a:pPr/>
-              <a:t>5/1/2026</a:t>
+              <a:t>5/19/2026</a:t>
             </a:fld>
             <a:endParaRPr lang="en-US"/>
           </a:p>
@@ -3952,6 +3957,1402 @@
       </p:grpSpPr>
       <p:sp>
         <p:nvSpPr>
+          <p:cNvPr id="2" name="Title 1">
+            <a:extLst>
+              <a:ext uri="{FF2B5EF4-FFF2-40B4-BE49-F238E27FC236}">
+                <a16:creationId xmlns:a16="http://schemas.microsoft.com/office/drawing/2014/main" id="{0E0A953C-1ED2-6CC3-6D87-C58BB814EBCB}"/>
+              </a:ext>
+            </a:extLst>
+          </p:cNvPr>
+          <p:cNvSpPr>
+            <a:spLocks noGrp="1"/>
+          </p:cNvSpPr>
+          <p:nvPr>
+            <p:ph type="title"/>
+          </p:nvPr>
+        </p:nvSpPr>
+        <p:spPr>
+          <a:xfrm>
+            <a:off x="-1" y="0"/>
+            <a:ext cx="5683045" cy="1160206"/>
+          </a:xfrm>
+        </p:spPr>
+        <p:txBody>
+          <a:bodyPr/>
+          <a:lstStyle/>
+          <a:p>
+            <a:r>
+              <a:rPr lang="en-US" sz="3000" b="1" dirty="0"/>
+              <a:t>Proposed Solution - Method Used (CNN / RMR-CNN)</a:t>
+            </a:r>
+            <a:br>
+              <a:rPr lang="en-US" sz="3000" b="1" dirty="0"/>
+            </a:br>
+            <a:endParaRPr lang="en-IN" sz="3000" dirty="0"/>
+          </a:p>
+        </p:txBody>
+      </p:sp>
+      <p:sp>
+        <p:nvSpPr>
+          <p:cNvPr id="3" name="Text Placeholder 2">
+            <a:extLst>
+              <a:ext uri="{FF2B5EF4-FFF2-40B4-BE49-F238E27FC236}">
+                <a16:creationId xmlns:a16="http://schemas.microsoft.com/office/drawing/2014/main" id="{CC3FA738-79C3-D34F-A077-372BBBC8D6B1}"/>
+              </a:ext>
+            </a:extLst>
+          </p:cNvPr>
+          <p:cNvSpPr>
+            <a:spLocks noGrp="1"/>
+          </p:cNvSpPr>
+          <p:nvPr>
+            <p:ph type="body"/>
+          </p:nvPr>
+        </p:nvSpPr>
+        <p:spPr>
+          <a:xfrm>
+            <a:off x="-1" y="1061884"/>
+            <a:ext cx="9075175" cy="5633884"/>
+          </a:xfrm>
+        </p:spPr>
+        <p:txBody>
+          <a:bodyPr>
+            <a:normAutofit fontScale="92500" lnSpcReduction="10000"/>
+          </a:bodyPr>
+          <a:lstStyle/>
+          <a:p>
+            <a:pPr marL="457200" indent="-457200">
+              <a:buFont typeface="Arial" panose="020B0604020202020204" pitchFamily="34" charset="0"/>
+              <a:buChar char="•"/>
+            </a:pPr>
+            <a:r>
+              <a:rPr lang="en-IN" sz="3100" b="1" dirty="0"/>
+              <a:t>Refined Mask R-CNN (RMR-CNN) Architecture</a:t>
+            </a:r>
+            <a:endParaRPr lang="en-IN" sz="3100" dirty="0"/>
+          </a:p>
+          <a:p>
+            <a:pPr marL="342900" indent="-342900">
+              <a:buFont typeface="Arial" panose="020B0604020202020204" pitchFamily="34" charset="0"/>
+              <a:buChar char="•"/>
+            </a:pPr>
+            <a:r>
+              <a:rPr lang="en-IN" sz="2300" b="1" dirty="0"/>
+              <a:t>Why Mask R-CNN?</a:t>
+            </a:r>
+            <a:endParaRPr lang="en-IN" sz="2300" dirty="0"/>
+          </a:p>
+          <a:p>
+            <a:pPr marL="342900" indent="-342900">
+              <a:buFont typeface="Arial" panose="020B0604020202020204" pitchFamily="34" charset="0"/>
+              <a:buChar char="•"/>
+            </a:pPr>
+            <a:r>
+              <a:rPr lang="en-IN" sz="2300" dirty="0"/>
+              <a:t>Faster R-CNN provides only bounding boxes (includes both object and background pixels)</a:t>
+            </a:r>
+          </a:p>
+          <a:p>
+            <a:pPr marL="342900" indent="-342900">
+              <a:buFont typeface="Arial" panose="020B0604020202020204" pitchFamily="34" charset="0"/>
+              <a:buChar char="•"/>
+            </a:pPr>
+            <a:r>
+              <a:rPr lang="en-IN" sz="2300" b="1" dirty="0"/>
+              <a:t>Mask R-CNN</a:t>
+            </a:r>
+            <a:r>
+              <a:rPr lang="en-IN" sz="2300" dirty="0"/>
+              <a:t> outputs a binary mask to determine whether a pixel belongs to a particular object → higher precision</a:t>
+            </a:r>
+          </a:p>
+          <a:p>
+            <a:pPr marL="342900" indent="-342900">
+              <a:buFont typeface="Arial" panose="020B0604020202020204" pitchFamily="34" charset="0"/>
+              <a:buChar char="•"/>
+            </a:pPr>
+            <a:r>
+              <a:rPr lang="en-IN" sz="2300" b="1" dirty="0"/>
+              <a:t>Our Refinements (RMR-CNN):</a:t>
+            </a:r>
+            <a:endParaRPr lang="en-IN" sz="2300" dirty="0"/>
+          </a:p>
+          <a:p>
+            <a:pPr marL="342900" indent="-342900">
+              <a:buFont typeface="Arial" panose="020B0604020202020204" pitchFamily="34" charset="0"/>
+              <a:buChar char="•"/>
+            </a:pPr>
+            <a:r>
+              <a:rPr lang="en-IN" sz="2300" b="1" dirty="0"/>
+              <a:t>Architectural Improvements</a:t>
+            </a:r>
+            <a:endParaRPr lang="en-IN" sz="2300" dirty="0"/>
+          </a:p>
+          <a:p>
+            <a:pPr marL="342900" lvl="1" indent="-342900">
+              <a:buFont typeface="Arial" panose="020B0604020202020204" pitchFamily="34" charset="0"/>
+              <a:buChar char="•"/>
+            </a:pPr>
+            <a:r>
+              <a:rPr lang="en-IN" sz="2300" dirty="0"/>
+              <a:t>Enhanced feature extraction layers</a:t>
+            </a:r>
+          </a:p>
+          <a:p>
+            <a:pPr marL="342900" lvl="1" indent="-342900">
+              <a:buFont typeface="Arial" panose="020B0604020202020204" pitchFamily="34" charset="0"/>
+              <a:buChar char="•"/>
+            </a:pPr>
+            <a:r>
+              <a:rPr lang="en-IN" sz="2300" dirty="0"/>
+              <a:t>Optimized region proposal network</a:t>
+            </a:r>
+          </a:p>
+          <a:p>
+            <a:pPr marL="342900" indent="-342900">
+              <a:buFont typeface="Arial" panose="020B0604020202020204" pitchFamily="34" charset="0"/>
+              <a:buChar char="•"/>
+            </a:pPr>
+            <a:r>
+              <a:rPr lang="en-IN" sz="2300" b="1" dirty="0"/>
+              <a:t>Parameter Tuning</a:t>
+            </a:r>
+            <a:endParaRPr lang="en-IN" sz="2300" dirty="0"/>
+          </a:p>
+          <a:p>
+            <a:pPr marL="342900" lvl="1" indent="-342900">
+              <a:buFont typeface="Arial" panose="020B0604020202020204" pitchFamily="34" charset="0"/>
+              <a:buChar char="•"/>
+            </a:pPr>
+            <a:r>
+              <a:rPr lang="en-IN" sz="2300" dirty="0"/>
+              <a:t>Adjusted parametric values to adapt Mask R-CNN to Indian traffic sign requirements</a:t>
+            </a:r>
+          </a:p>
+          <a:p>
+            <a:pPr marL="342900" indent="-342900">
+              <a:buFont typeface="Arial" panose="020B0604020202020204" pitchFamily="34" charset="0"/>
+              <a:buChar char="•"/>
+            </a:pPr>
+            <a:r>
+              <a:rPr lang="en-IN" sz="2300" b="1" dirty="0"/>
+              <a:t>Data Augmentation</a:t>
+            </a:r>
+            <a:endParaRPr lang="en-IN" sz="2300" dirty="0"/>
+          </a:p>
+          <a:p>
+            <a:pPr marL="342900" lvl="1" indent="-342900">
+              <a:buFont typeface="Arial" panose="020B0604020202020204" pitchFamily="34" charset="0"/>
+              <a:buChar char="•"/>
+            </a:pPr>
+            <a:r>
+              <a:rPr lang="en-IN" sz="2300" dirty="0"/>
+              <a:t>Scaling, rotation, lighting variation simulation</a:t>
+            </a:r>
+          </a:p>
+          <a:p>
+            <a:pPr marL="342900" indent="-342900">
+              <a:buFont typeface="Arial" panose="020B0604020202020204" pitchFamily="34" charset="0"/>
+              <a:buChar char="•"/>
+            </a:pPr>
+            <a:r>
+              <a:rPr lang="en-IN" sz="2300" b="1" dirty="0"/>
+              <a:t>Pre-processing Enhancements</a:t>
+            </a:r>
+            <a:r>
+              <a:rPr lang="en-IN" sz="2300" dirty="0"/>
+              <a:t> (3 key steps):</a:t>
+            </a:r>
+          </a:p>
+          <a:p>
+            <a:pPr marL="342900" lvl="1" indent="-342900">
+              <a:buFont typeface="Arial" panose="020B0604020202020204" pitchFamily="34" charset="0"/>
+              <a:buChar char="•"/>
+            </a:pPr>
+            <a:r>
+              <a:rPr lang="en-IN" sz="2300" dirty="0"/>
+              <a:t>Shape detection (triangles, rectangles, circles)</a:t>
+            </a:r>
+          </a:p>
+          <a:p>
+            <a:pPr marL="342900" lvl="1" indent="-342900">
+              <a:buFont typeface="Arial" panose="020B0604020202020204" pitchFamily="34" charset="0"/>
+              <a:buChar char="•"/>
+            </a:pPr>
+            <a:r>
+              <a:rPr lang="en-IN" sz="2300" dirty="0"/>
+              <a:t>Region of Interest (ROI) extraction</a:t>
+            </a:r>
+          </a:p>
+          <a:p>
+            <a:pPr marL="342900" lvl="1" indent="-342900">
+              <a:buFont typeface="Arial" panose="020B0604020202020204" pitchFamily="34" charset="0"/>
+              <a:buChar char="•"/>
+            </a:pPr>
+            <a:r>
+              <a:rPr lang="en-IN" sz="2300" dirty="0" err="1"/>
+              <a:t>Color</a:t>
+            </a:r>
+            <a:r>
+              <a:rPr lang="en-IN" sz="2300" dirty="0"/>
+              <a:t> probability analysis</a:t>
+            </a:r>
+          </a:p>
+          <a:p>
+            <a:pPr marL="342900" indent="-342900">
+              <a:buFont typeface="Arial" panose="020B0604020202020204" pitchFamily="34" charset="0"/>
+              <a:buChar char="•"/>
+            </a:pPr>
+            <a:r>
+              <a:rPr lang="en-IN" sz="2300" b="1" dirty="0"/>
+              <a:t>Result:</a:t>
+            </a:r>
+            <a:r>
+              <a:rPr lang="en-IN" sz="2300" dirty="0"/>
+              <a:t> Higher accuracy than standard Mask R-CNN and Faster R-CNN</a:t>
+            </a:r>
+          </a:p>
+          <a:p>
+            <a:endParaRPr lang="en-IN" dirty="0"/>
+          </a:p>
+        </p:txBody>
+      </p:sp>
+    </p:spTree>
+    <p:extLst>
+      <p:ext uri="{BB962C8B-B14F-4D97-AF65-F5344CB8AC3E}">
+        <p14:creationId xmlns:p14="http://schemas.microsoft.com/office/powerpoint/2010/main" val="2357732677"/>
+      </p:ext>
+    </p:extLst>
+  </p:cSld>
+  <p:clrMapOvr>
+    <a:masterClrMapping/>
+  </p:clrMapOvr>
+</p:sld>
+</file>
+
+<file path=ppt/slides/slide11.xml><?xml version="1.0" encoding="utf-8"?>
+<p:sld xmlns:a="http://schemas.openxmlformats.org/drawingml/2006/main" xmlns:r="http://schemas.openxmlformats.org/officeDocument/2006/relationships" xmlns:p="http://schemas.openxmlformats.org/presentationml/2006/main">
+  <p:cSld>
+    <p:spTree>
+      <p:nvGrpSpPr>
+        <p:cNvPr id="1" name=""/>
+        <p:cNvGrpSpPr/>
+        <p:nvPr/>
+      </p:nvGrpSpPr>
+      <p:grpSpPr>
+        <a:xfrm>
+          <a:off x="0" y="0"/>
+          <a:ext cx="0" cy="0"/>
+          <a:chOff x="0" y="0"/>
+          <a:chExt cx="0" cy="0"/>
+        </a:xfrm>
+      </p:grpSpPr>
+      <p:pic>
+        <p:nvPicPr>
+          <p:cNvPr id="3" name="Picture 2">
+            <a:extLst>
+              <a:ext uri="{FF2B5EF4-FFF2-40B4-BE49-F238E27FC236}">
+                <a16:creationId xmlns:a16="http://schemas.microsoft.com/office/drawing/2014/main" id="{50BE15DE-1574-4D8F-8D08-96B139E22A59}"/>
+              </a:ext>
+            </a:extLst>
+          </p:cNvPr>
+          <p:cNvPicPr>
+            <a:picLocks noChangeAspect="1"/>
+          </p:cNvPicPr>
+          <p:nvPr/>
+        </p:nvPicPr>
+        <p:blipFill>
+          <a:blip r:embed="rId2">
+            <a:extLst>
+              <a:ext uri="{28A0092B-C50C-407E-A947-70E740481C1C}">
+                <a14:useLocalDpi xmlns:a14="http://schemas.microsoft.com/office/drawing/2010/main" val="0"/>
+              </a:ext>
+            </a:extLst>
+          </a:blip>
+          <a:stretch>
+            <a:fillRect/>
+          </a:stretch>
+        </p:blipFill>
+        <p:spPr>
+          <a:xfrm>
+            <a:off x="958645" y="833283"/>
+            <a:ext cx="7226710" cy="5781369"/>
+          </a:xfrm>
+          <a:prstGeom prst="rect">
+            <a:avLst/>
+          </a:prstGeom>
+        </p:spPr>
+      </p:pic>
+    </p:spTree>
+    <p:extLst>
+      <p:ext uri="{BB962C8B-B14F-4D97-AF65-F5344CB8AC3E}">
+        <p14:creationId xmlns:p14="http://schemas.microsoft.com/office/powerpoint/2010/main" val="906583993"/>
+      </p:ext>
+    </p:extLst>
+  </p:cSld>
+  <p:clrMapOvr>
+    <a:masterClrMapping/>
+  </p:clrMapOvr>
+</p:sld>
+</file>
+
+<file path=ppt/slides/slide12.xml><?xml version="1.0" encoding="utf-8"?>
+<p:sld xmlns:a="http://schemas.openxmlformats.org/drawingml/2006/main" xmlns:r="http://schemas.openxmlformats.org/officeDocument/2006/relationships" xmlns:p="http://schemas.openxmlformats.org/presentationml/2006/main">
+  <p:cSld>
+    <p:spTree>
+      <p:nvGrpSpPr>
+        <p:cNvPr id="1" name=""/>
+        <p:cNvGrpSpPr/>
+        <p:nvPr/>
+      </p:nvGrpSpPr>
+      <p:grpSpPr>
+        <a:xfrm>
+          <a:off x="0" y="0"/>
+          <a:ext cx="0" cy="0"/>
+          <a:chOff x="0" y="0"/>
+          <a:chExt cx="0" cy="0"/>
+        </a:xfrm>
+      </p:grpSpPr>
+      <p:sp>
+        <p:nvSpPr>
+          <p:cNvPr id="2" name="Title 1">
+            <a:extLst>
+              <a:ext uri="{FF2B5EF4-FFF2-40B4-BE49-F238E27FC236}">
+                <a16:creationId xmlns:a16="http://schemas.microsoft.com/office/drawing/2014/main" id="{023E351A-841C-0E23-D95C-C13DDF8C7CBF}"/>
+              </a:ext>
+            </a:extLst>
+          </p:cNvPr>
+          <p:cNvSpPr>
+            <a:spLocks noGrp="1"/>
+          </p:cNvSpPr>
+          <p:nvPr>
+            <p:ph type="title"/>
+          </p:nvPr>
+        </p:nvSpPr>
+        <p:spPr>
+          <a:xfrm>
+            <a:off x="0" y="-1"/>
+            <a:ext cx="6390968" cy="1170039"/>
+          </a:xfrm>
+        </p:spPr>
+        <p:txBody>
+          <a:bodyPr/>
+          <a:lstStyle/>
+          <a:p>
+            <a:pPr>
+              <a:lnSpc>
+                <a:spcPts val="2400"/>
+              </a:lnSpc>
+              <a:spcBef>
+                <a:spcPts val="2400"/>
+              </a:spcBef>
+              <a:spcAft>
+                <a:spcPts val="1200"/>
+              </a:spcAft>
+            </a:pPr>
+            <a:r>
+              <a:rPr lang="en-IN" b="1" dirty="0">
+                <a:solidFill>
+                  <a:srgbClr val="0F1115"/>
+                </a:solidFill>
+                <a:effectLst/>
+                <a:latin typeface="quote-cjk-patch"/>
+              </a:rPr>
+              <a:t>Dataset &amp; Preprocessing</a:t>
+            </a:r>
+            <a:br>
+              <a:rPr lang="en-IN" b="1" dirty="0">
+                <a:solidFill>
+                  <a:srgbClr val="0F1115"/>
+                </a:solidFill>
+                <a:effectLst/>
+                <a:latin typeface="quote-cjk-patch"/>
+              </a:rPr>
+            </a:br>
+            <a:endParaRPr lang="en-IN" dirty="0"/>
+          </a:p>
+        </p:txBody>
+      </p:sp>
+      <p:graphicFrame>
+        <p:nvGraphicFramePr>
+          <p:cNvPr id="11" name="Table 10">
+            <a:extLst>
+              <a:ext uri="{FF2B5EF4-FFF2-40B4-BE49-F238E27FC236}">
+                <a16:creationId xmlns:a16="http://schemas.microsoft.com/office/drawing/2014/main" id="{4EB8FBBE-B163-567D-EC06-BEAAC7A98C5A}"/>
+              </a:ext>
+            </a:extLst>
+          </p:cNvPr>
+          <p:cNvGraphicFramePr>
+            <a:graphicFrameLocks noGrp="1"/>
+          </p:cNvGraphicFramePr>
+          <p:nvPr>
+            <p:extLst>
+              <p:ext uri="{D42A27DB-BD31-4B8C-83A1-F6EECF244321}">
+                <p14:modId xmlns:p14="http://schemas.microsoft.com/office/powerpoint/2010/main" val="2149345640"/>
+              </p:ext>
+            </p:extLst>
+          </p:nvPr>
+        </p:nvGraphicFramePr>
+        <p:xfrm>
+          <a:off x="381490" y="1839313"/>
+          <a:ext cx="5861994" cy="2693357"/>
+        </p:xfrm>
+        <a:graphic>
+          <a:graphicData uri="http://schemas.openxmlformats.org/drawingml/2006/table">
+            <a:tbl>
+              <a:tblPr/>
+              <a:tblGrid>
+                <a:gridCol w="2930997">
+                  <a:extLst>
+                    <a:ext uri="{9D8B030D-6E8A-4147-A177-3AD203B41FA5}">
+                      <a16:colId xmlns:a16="http://schemas.microsoft.com/office/drawing/2014/main" val="1211643700"/>
+                    </a:ext>
+                  </a:extLst>
+                </a:gridCol>
+                <a:gridCol w="2930997">
+                  <a:extLst>
+                    <a:ext uri="{9D8B030D-6E8A-4147-A177-3AD203B41FA5}">
+                      <a16:colId xmlns:a16="http://schemas.microsoft.com/office/drawing/2014/main" val="1141460696"/>
+                    </a:ext>
+                  </a:extLst>
+                </a:gridCol>
+              </a:tblGrid>
+              <a:tr h="407288">
+                <a:tc>
+                  <a:txBody>
+                    <a:bodyPr/>
+                    <a:lstStyle/>
+                    <a:p>
+                      <a:pPr algn="l">
+                        <a:lnSpc>
+                          <a:spcPts val="1875"/>
+                        </a:lnSpc>
+                        <a:buNone/>
+                      </a:pPr>
+                      <a:r>
+                        <a:rPr lang="en-IN" b="0">
+                          <a:effectLst/>
+                          <a:latin typeface="quote-cjk-patch"/>
+                        </a:rPr>
+                        <a:t>Parameter</a:t>
+                      </a:r>
+                    </a:p>
+                  </a:txBody>
+                  <a:tcPr marR="121920" marT="76200" marB="76200" anchor="ctr">
+                    <a:lnL>
+                      <a:noFill/>
+                    </a:lnL>
+                    <a:lnR>
+                      <a:noFill/>
+                    </a:lnR>
+                    <a:lnT>
+                      <a:noFill/>
+                    </a:lnT>
+                    <a:lnB>
+                      <a:noFill/>
+                    </a:lnB>
+                    <a:noFill/>
+                  </a:tcPr>
+                </a:tc>
+                <a:tc>
+                  <a:txBody>
+                    <a:bodyPr/>
+                    <a:lstStyle/>
+                    <a:p>
+                      <a:pPr algn="l">
+                        <a:lnSpc>
+                          <a:spcPts val="1875"/>
+                        </a:lnSpc>
+                        <a:buNone/>
+                      </a:pPr>
+                      <a:r>
+                        <a:rPr lang="en-IN" b="0">
+                          <a:effectLst/>
+                          <a:latin typeface="quote-cjk-patch"/>
+                        </a:rPr>
+                        <a:t>Value</a:t>
+                      </a:r>
+                    </a:p>
+                  </a:txBody>
+                  <a:tcPr marL="121920" marR="121920" marT="76200" marB="76200" anchor="ctr">
+                    <a:lnL>
+                      <a:noFill/>
+                    </a:lnL>
+                    <a:lnR>
+                      <a:noFill/>
+                    </a:lnR>
+                    <a:lnT>
+                      <a:noFill/>
+                    </a:lnT>
+                    <a:lnB>
+                      <a:noFill/>
+                    </a:lnB>
+                    <a:noFill/>
+                  </a:tcPr>
+                </a:tc>
+                <a:extLst>
+                  <a:ext uri="{0D108BD9-81ED-4DB2-BD59-A6C34878D82A}">
+                    <a16:rowId xmlns:a16="http://schemas.microsoft.com/office/drawing/2014/main" val="1058154417"/>
+                  </a:ext>
+                </a:extLst>
+              </a:tr>
+              <a:tr h="407288">
+                <a:tc>
+                  <a:txBody>
+                    <a:bodyPr/>
+                    <a:lstStyle/>
+                    <a:p>
+                      <a:pPr>
+                        <a:lnSpc>
+                          <a:spcPts val="1875"/>
+                        </a:lnSpc>
+                        <a:buNone/>
+                      </a:pPr>
+                      <a:r>
+                        <a:rPr lang="en-IN" b="0" dirty="0">
+                          <a:effectLst/>
+                          <a:latin typeface="quote-cjk-patch"/>
+                        </a:rPr>
+                        <a:t>Total Images</a:t>
+                      </a:r>
+                    </a:p>
+                  </a:txBody>
+                  <a:tcPr marR="121920" marT="76200" marB="76200" anchor="ctr">
+                    <a:lnL>
+                      <a:noFill/>
+                    </a:lnL>
+                    <a:lnR>
+                      <a:noFill/>
+                    </a:lnR>
+                    <a:lnT>
+                      <a:noFill/>
+                    </a:lnT>
+                    <a:lnB>
+                      <a:noFill/>
+                    </a:lnB>
+                    <a:noFill/>
+                  </a:tcPr>
+                </a:tc>
+                <a:tc>
+                  <a:txBody>
+                    <a:bodyPr/>
+                    <a:lstStyle/>
+                    <a:p>
+                      <a:pPr>
+                        <a:lnSpc>
+                          <a:spcPts val="1875"/>
+                        </a:lnSpc>
+                        <a:buNone/>
+                      </a:pPr>
+                      <a:r>
+                        <a:rPr lang="en-IN" b="0">
+                          <a:effectLst/>
+                          <a:latin typeface="quote-cjk-patch"/>
+                        </a:rPr>
+                        <a:t>6,480</a:t>
+                      </a:r>
+                    </a:p>
+                  </a:txBody>
+                  <a:tcPr marL="121920" marT="76200" marB="76200" anchor="ctr">
+                    <a:lnL>
+                      <a:noFill/>
+                    </a:lnL>
+                    <a:lnR>
+                      <a:noFill/>
+                    </a:lnR>
+                    <a:lnT>
+                      <a:noFill/>
+                    </a:lnT>
+                    <a:lnB>
+                      <a:noFill/>
+                    </a:lnB>
+                    <a:noFill/>
+                  </a:tcPr>
+                </a:tc>
+                <a:extLst>
+                  <a:ext uri="{0D108BD9-81ED-4DB2-BD59-A6C34878D82A}">
+                    <a16:rowId xmlns:a16="http://schemas.microsoft.com/office/drawing/2014/main" val="2287787102"/>
+                  </a:ext>
+                </a:extLst>
+              </a:tr>
+              <a:tr h="407288">
+                <a:tc>
+                  <a:txBody>
+                    <a:bodyPr/>
+                    <a:lstStyle/>
+                    <a:p>
+                      <a:pPr>
+                        <a:lnSpc>
+                          <a:spcPts val="1875"/>
+                        </a:lnSpc>
+                        <a:buNone/>
+                      </a:pPr>
+                      <a:r>
+                        <a:rPr lang="en-IN" b="0">
+                          <a:effectLst/>
+                          <a:latin typeface="quote-cjk-patch"/>
+                        </a:rPr>
+                        <a:t>Total Traffic Sign Instances</a:t>
+                      </a:r>
+                    </a:p>
+                  </a:txBody>
+                  <a:tcPr marR="121920" marT="76200" marB="76200" anchor="ctr">
+                    <a:lnL>
+                      <a:noFill/>
+                    </a:lnL>
+                    <a:lnR>
+                      <a:noFill/>
+                    </a:lnR>
+                    <a:lnT>
+                      <a:noFill/>
+                    </a:lnT>
+                    <a:lnB>
+                      <a:noFill/>
+                    </a:lnB>
+                    <a:noFill/>
+                  </a:tcPr>
+                </a:tc>
+                <a:tc>
+                  <a:txBody>
+                    <a:bodyPr/>
+                    <a:lstStyle/>
+                    <a:p>
+                      <a:pPr>
+                        <a:lnSpc>
+                          <a:spcPts val="1875"/>
+                        </a:lnSpc>
+                        <a:buNone/>
+                      </a:pPr>
+                      <a:r>
+                        <a:rPr lang="en-IN" b="0">
+                          <a:effectLst/>
+                          <a:latin typeface="quote-cjk-patch"/>
+                        </a:rPr>
+                        <a:t>7,056</a:t>
+                      </a:r>
+                    </a:p>
+                  </a:txBody>
+                  <a:tcPr marL="121920" marT="76200" marB="76200" anchor="ctr">
+                    <a:lnL>
+                      <a:noFill/>
+                    </a:lnL>
+                    <a:lnR>
+                      <a:noFill/>
+                    </a:lnR>
+                    <a:lnT>
+                      <a:noFill/>
+                    </a:lnT>
+                    <a:lnB>
+                      <a:noFill/>
+                    </a:lnB>
+                    <a:noFill/>
+                  </a:tcPr>
+                </a:tc>
+                <a:extLst>
+                  <a:ext uri="{0D108BD9-81ED-4DB2-BD59-A6C34878D82A}">
+                    <a16:rowId xmlns:a16="http://schemas.microsoft.com/office/drawing/2014/main" val="3285033943"/>
+                  </a:ext>
+                </a:extLst>
+              </a:tr>
+              <a:tr h="407288">
+                <a:tc>
+                  <a:txBody>
+                    <a:bodyPr/>
+                    <a:lstStyle/>
+                    <a:p>
+                      <a:pPr>
+                        <a:lnSpc>
+                          <a:spcPts val="1875"/>
+                        </a:lnSpc>
+                        <a:buNone/>
+                      </a:pPr>
+                      <a:r>
+                        <a:rPr lang="en-IN" b="0" dirty="0">
+                          <a:effectLst/>
+                          <a:latin typeface="quote-cjk-patch"/>
+                        </a:rPr>
+                        <a:t>Categories (Indian signs)</a:t>
+                      </a:r>
+                    </a:p>
+                  </a:txBody>
+                  <a:tcPr marR="121920" marT="76200" marB="76200" anchor="ctr">
+                    <a:lnL>
+                      <a:noFill/>
+                    </a:lnL>
+                    <a:lnR>
+                      <a:noFill/>
+                    </a:lnR>
+                    <a:lnT>
+                      <a:noFill/>
+                    </a:lnT>
+                    <a:lnB>
+                      <a:noFill/>
+                    </a:lnB>
+                    <a:noFill/>
+                  </a:tcPr>
+                </a:tc>
+                <a:tc>
+                  <a:txBody>
+                    <a:bodyPr/>
+                    <a:lstStyle/>
+                    <a:p>
+                      <a:pPr>
+                        <a:lnSpc>
+                          <a:spcPts val="1875"/>
+                        </a:lnSpc>
+                        <a:buNone/>
+                      </a:pPr>
+                      <a:r>
+                        <a:rPr lang="en-IN" b="0">
+                          <a:effectLst/>
+                          <a:latin typeface="quote-cjk-patch"/>
+                        </a:rPr>
+                        <a:t>87</a:t>
+                      </a:r>
+                    </a:p>
+                  </a:txBody>
+                  <a:tcPr marL="121920" marT="76200" marB="76200" anchor="ctr">
+                    <a:lnL>
+                      <a:noFill/>
+                    </a:lnL>
+                    <a:lnR>
+                      <a:noFill/>
+                    </a:lnR>
+                    <a:lnT>
+                      <a:noFill/>
+                    </a:lnT>
+                    <a:lnB>
+                      <a:noFill/>
+                    </a:lnB>
+                    <a:noFill/>
+                  </a:tcPr>
+                </a:tc>
+                <a:extLst>
+                  <a:ext uri="{0D108BD9-81ED-4DB2-BD59-A6C34878D82A}">
+                    <a16:rowId xmlns:a16="http://schemas.microsoft.com/office/drawing/2014/main" val="3166671730"/>
+                  </a:ext>
+                </a:extLst>
+              </a:tr>
+              <a:tr h="656917">
+                <a:tc>
+                  <a:txBody>
+                    <a:bodyPr/>
+                    <a:lstStyle/>
+                    <a:p>
+                      <a:pPr>
+                        <a:lnSpc>
+                          <a:spcPts val="1875"/>
+                        </a:lnSpc>
+                        <a:buNone/>
+                      </a:pPr>
+                      <a:r>
+                        <a:rPr lang="en-IN" b="0">
+                          <a:effectLst/>
+                          <a:latin typeface="quote-cjk-patch"/>
+                        </a:rPr>
+                        <a:t>Categories (from standard datasets)</a:t>
+                      </a:r>
+                    </a:p>
+                  </a:txBody>
+                  <a:tcPr marR="121920" marT="76200" marB="76200" anchor="ctr">
+                    <a:lnL>
+                      <a:noFill/>
+                    </a:lnL>
+                    <a:lnR>
+                      <a:noFill/>
+                    </a:lnR>
+                    <a:lnT>
+                      <a:noFill/>
+                    </a:lnT>
+                    <a:lnB>
+                      <a:noFill/>
+                    </a:lnB>
+                    <a:noFill/>
+                  </a:tcPr>
+                </a:tc>
+                <a:tc>
+                  <a:txBody>
+                    <a:bodyPr/>
+                    <a:lstStyle/>
+                    <a:p>
+                      <a:pPr>
+                        <a:lnSpc>
+                          <a:spcPts val="1875"/>
+                        </a:lnSpc>
+                        <a:buNone/>
+                      </a:pPr>
+                      <a:r>
+                        <a:rPr lang="en-IN" b="0">
+                          <a:effectLst/>
+                          <a:latin typeface="quote-cjk-patch"/>
+                        </a:rPr>
+                        <a:t>13</a:t>
+                      </a:r>
+                    </a:p>
+                  </a:txBody>
+                  <a:tcPr marL="121920" marT="76200" marB="76200" anchor="ctr">
+                    <a:lnL>
+                      <a:noFill/>
+                    </a:lnL>
+                    <a:lnR>
+                      <a:noFill/>
+                    </a:lnR>
+                    <a:lnT>
+                      <a:noFill/>
+                    </a:lnT>
+                    <a:lnB>
+                      <a:noFill/>
+                    </a:lnB>
+                    <a:noFill/>
+                  </a:tcPr>
+                </a:tc>
+                <a:extLst>
+                  <a:ext uri="{0D108BD9-81ED-4DB2-BD59-A6C34878D82A}">
+                    <a16:rowId xmlns:a16="http://schemas.microsoft.com/office/drawing/2014/main" val="123367131"/>
+                  </a:ext>
+                </a:extLst>
+              </a:tr>
+              <a:tr h="407288">
+                <a:tc>
+                  <a:txBody>
+                    <a:bodyPr/>
+                    <a:lstStyle/>
+                    <a:p>
+                      <a:pPr>
+                        <a:lnSpc>
+                          <a:spcPts val="1875"/>
+                        </a:lnSpc>
+                        <a:buNone/>
+                      </a:pPr>
+                      <a:r>
+                        <a:rPr lang="en-IN" b="1">
+                          <a:effectLst/>
+                          <a:latin typeface="quote-cjk-patch"/>
+                        </a:rPr>
+                        <a:t>Total Categories</a:t>
+                      </a:r>
+                      <a:endParaRPr lang="en-IN" b="0">
+                        <a:effectLst/>
+                        <a:latin typeface="quote-cjk-patch"/>
+                      </a:endParaRPr>
+                    </a:p>
+                  </a:txBody>
+                  <a:tcPr marR="121920" marT="76200" marB="76200" anchor="ctr">
+                    <a:lnL>
+                      <a:noFill/>
+                    </a:lnL>
+                    <a:lnR>
+                      <a:noFill/>
+                    </a:lnR>
+                    <a:lnT>
+                      <a:noFill/>
+                    </a:lnT>
+                    <a:lnB>
+                      <a:noFill/>
+                    </a:lnB>
+                    <a:noFill/>
+                  </a:tcPr>
+                </a:tc>
+                <a:tc>
+                  <a:txBody>
+                    <a:bodyPr/>
+                    <a:lstStyle/>
+                    <a:p>
+                      <a:pPr>
+                        <a:lnSpc>
+                          <a:spcPts val="1875"/>
+                        </a:lnSpc>
+                        <a:buNone/>
+                      </a:pPr>
+                      <a:r>
+                        <a:rPr lang="en-IN" b="1" dirty="0">
+                          <a:effectLst/>
+                          <a:latin typeface="quote-cjk-patch"/>
+                        </a:rPr>
+                        <a:t>100</a:t>
+                      </a:r>
+                      <a:endParaRPr lang="en-IN" b="0" dirty="0">
+                        <a:effectLst/>
+                        <a:latin typeface="quote-cjk-patch"/>
+                      </a:endParaRPr>
+                    </a:p>
+                  </a:txBody>
+                  <a:tcPr marL="121920" marT="76200" marB="76200" anchor="ctr">
+                    <a:lnL>
+                      <a:noFill/>
+                    </a:lnL>
+                    <a:lnR>
+                      <a:noFill/>
+                    </a:lnR>
+                    <a:lnT>
+                      <a:noFill/>
+                    </a:lnT>
+                    <a:lnB>
+                      <a:noFill/>
+                    </a:lnB>
+                    <a:noFill/>
+                  </a:tcPr>
+                </a:tc>
+                <a:extLst>
+                  <a:ext uri="{0D108BD9-81ED-4DB2-BD59-A6C34878D82A}">
+                    <a16:rowId xmlns:a16="http://schemas.microsoft.com/office/drawing/2014/main" val="2477501240"/>
+                  </a:ext>
+                </a:extLst>
+              </a:tr>
+            </a:tbl>
+          </a:graphicData>
+        </a:graphic>
+      </p:graphicFrame>
+      <p:sp>
+        <p:nvSpPr>
+          <p:cNvPr id="12" name="Rectangle 5">
+            <a:extLst>
+              <a:ext uri="{FF2B5EF4-FFF2-40B4-BE49-F238E27FC236}">
+                <a16:creationId xmlns:a16="http://schemas.microsoft.com/office/drawing/2014/main" id="{AE8D7373-CDB3-2EED-D3D9-1C7D1768C0AF}"/>
+              </a:ext>
+            </a:extLst>
+          </p:cNvPr>
+          <p:cNvSpPr>
+            <a:spLocks noGrp="1" noChangeArrowheads="1"/>
+          </p:cNvSpPr>
+          <p:nvPr>
+            <p:ph type="body"/>
+          </p:nvPr>
+        </p:nvSpPr>
+        <p:spPr bwMode="auto">
+          <a:xfrm>
+            <a:off x="1" y="856339"/>
+            <a:ext cx="8927690" cy="1107996"/>
+          </a:xfrm>
+          <a:prstGeom prst="rect">
+            <a:avLst/>
+          </a:prstGeom>
+          <a:solidFill>
+            <a:srgbClr val="FFFFFF"/>
+          </a:solidFill>
+          <a:ln>
+            <a:noFill/>
+          </a:ln>
+          <a:effectLst/>
+          <a:extLst>
+            <a:ext uri="{91240B29-F687-4F45-9708-019B960494DF}">
+              <a14:hiddenLine xmlns:a14="http://schemas.microsoft.com/office/drawing/2010/main" w="9525">
+                <a:solidFill>
+                  <a:schemeClr val="tx1"/>
+                </a:solidFill>
+                <a:miter lim="800000"/>
+                <a:headEnd/>
+                <a:tailEnd/>
+              </a14:hiddenLine>
+            </a:ext>
+            <a:ext uri="{AF507438-7753-43E0-B8FC-AC1667EBCBE1}">
+              <a14:hiddenEffects xmlns:a14="http://schemas.microsoft.com/office/drawing/2010/main">
+                <a:effectLst>
+                  <a:outerShdw dist="35921" dir="2700000" algn="ctr" rotWithShape="0">
+                    <a:schemeClr val="bg2"/>
+                  </a:outerShdw>
+                </a:effectLst>
+              </a14:hiddenEffects>
+            </a:ext>
+          </a:extLst>
+        </p:spPr>
+        <p:txBody>
+          <a:bodyPr vert="horz" wrap="square" lIns="91440" tIns="45720" rIns="91440" bIns="45720" numCol="1" anchor="ctr" anchorCtr="0" compatLnSpc="1">
+            <a:prstTxWarp prst="textNoShape">
+              <a:avLst/>
+            </a:prstTxWarp>
+            <a:spAutoFit/>
+          </a:bodyPr>
+          <a:lstStyle>
+            <a:lvl1pPr eaLnBrk="0" fontAlgn="base" hangingPunct="0">
+              <a:spcBef>
+                <a:spcPct val="0"/>
+              </a:spcBef>
+              <a:spcAft>
+                <a:spcPct val="0"/>
+              </a:spcAft>
+              <a:defRPr>
+                <a:solidFill>
+                  <a:schemeClr val="tx1"/>
+                </a:solidFill>
+                <a:latin typeface="Arial" panose="020B0604020202020204" pitchFamily="34" charset="0"/>
+              </a:defRPr>
+            </a:lvl1pPr>
+            <a:lvl2pPr eaLnBrk="0" fontAlgn="base" hangingPunct="0">
+              <a:spcBef>
+                <a:spcPct val="0"/>
+              </a:spcBef>
+              <a:spcAft>
+                <a:spcPct val="0"/>
+              </a:spcAft>
+              <a:defRPr>
+                <a:solidFill>
+                  <a:schemeClr val="tx1"/>
+                </a:solidFill>
+                <a:latin typeface="Arial" panose="020B0604020202020204" pitchFamily="34" charset="0"/>
+              </a:defRPr>
+            </a:lvl2pPr>
+            <a:lvl3pPr eaLnBrk="0" fontAlgn="base" hangingPunct="0">
+              <a:spcBef>
+                <a:spcPct val="0"/>
+              </a:spcBef>
+              <a:spcAft>
+                <a:spcPct val="0"/>
+              </a:spcAft>
+              <a:defRPr>
+                <a:solidFill>
+                  <a:schemeClr val="tx1"/>
+                </a:solidFill>
+                <a:latin typeface="Arial" panose="020B0604020202020204" pitchFamily="34" charset="0"/>
+              </a:defRPr>
+            </a:lvl3pPr>
+            <a:lvl4pPr eaLnBrk="0" fontAlgn="base" hangingPunct="0">
+              <a:spcBef>
+                <a:spcPct val="0"/>
+              </a:spcBef>
+              <a:spcAft>
+                <a:spcPct val="0"/>
+              </a:spcAft>
+              <a:defRPr>
+                <a:solidFill>
+                  <a:schemeClr val="tx1"/>
+                </a:solidFill>
+                <a:latin typeface="Arial" panose="020B0604020202020204" pitchFamily="34" charset="0"/>
+              </a:defRPr>
+            </a:lvl4pPr>
+            <a:lvl5pPr eaLnBrk="0" fontAlgn="base" hangingPunct="0">
+              <a:spcBef>
+                <a:spcPct val="0"/>
+              </a:spcBef>
+              <a:spcAft>
+                <a:spcPct val="0"/>
+              </a:spcAft>
+              <a:defRPr>
+                <a:solidFill>
+                  <a:schemeClr val="tx1"/>
+                </a:solidFill>
+                <a:latin typeface="Arial" panose="020B0604020202020204" pitchFamily="34" charset="0"/>
+              </a:defRPr>
+            </a:lvl5pPr>
+            <a:lvl6pPr eaLnBrk="0" fontAlgn="base" hangingPunct="0">
+              <a:spcBef>
+                <a:spcPct val="0"/>
+              </a:spcBef>
+              <a:spcAft>
+                <a:spcPct val="0"/>
+              </a:spcAft>
+              <a:defRPr>
+                <a:solidFill>
+                  <a:schemeClr val="tx1"/>
+                </a:solidFill>
+                <a:latin typeface="Arial" panose="020B0604020202020204" pitchFamily="34" charset="0"/>
+              </a:defRPr>
+            </a:lvl6pPr>
+            <a:lvl7pPr eaLnBrk="0" fontAlgn="base" hangingPunct="0">
+              <a:spcBef>
+                <a:spcPct val="0"/>
+              </a:spcBef>
+              <a:spcAft>
+                <a:spcPct val="0"/>
+              </a:spcAft>
+              <a:defRPr>
+                <a:solidFill>
+                  <a:schemeClr val="tx1"/>
+                </a:solidFill>
+                <a:latin typeface="Arial" panose="020B0604020202020204" pitchFamily="34" charset="0"/>
+              </a:defRPr>
+            </a:lvl7pPr>
+            <a:lvl8pPr eaLnBrk="0" fontAlgn="base" hangingPunct="0">
+              <a:spcBef>
+                <a:spcPct val="0"/>
+              </a:spcBef>
+              <a:spcAft>
+                <a:spcPct val="0"/>
+              </a:spcAft>
+              <a:defRPr>
+                <a:solidFill>
+                  <a:schemeClr val="tx1"/>
+                </a:solidFill>
+                <a:latin typeface="Arial" panose="020B0604020202020204" pitchFamily="34" charset="0"/>
+              </a:defRPr>
+            </a:lvl8pPr>
+            <a:lvl9pPr eaLnBrk="0" fontAlgn="base" hangingPunct="0">
+              <a:spcBef>
+                <a:spcPct val="0"/>
+              </a:spcBef>
+              <a:spcAft>
+                <a:spcPct val="0"/>
+              </a:spcAft>
+              <a:defRPr>
+                <a:solidFill>
+                  <a:schemeClr val="tx1"/>
+                </a:solidFill>
+                <a:latin typeface="Arial" panose="020B0604020202020204" pitchFamily="34" charset="0"/>
+              </a:defRPr>
+            </a:lvl9pPr>
+          </a:lstStyle>
+          <a:p>
+            <a:pPr marL="0" marR="0" lvl="0" indent="0" algn="l" defTabSz="914400" rtl="0" eaLnBrk="0" fontAlgn="base" latinLnBrk="0" hangingPunct="0">
+              <a:lnSpc>
+                <a:spcPct val="100000"/>
+              </a:lnSpc>
+              <a:spcBef>
+                <a:spcPct val="0"/>
+              </a:spcBef>
+              <a:spcAft>
+                <a:spcPct val="0"/>
+              </a:spcAft>
+              <a:buClrTx/>
+              <a:buSzTx/>
+              <a:buFontTx/>
+              <a:buNone/>
+              <a:tabLst/>
+            </a:pPr>
+            <a:r>
+              <a:rPr kumimoji="0" lang="en-US" altLang="en-US" sz="2400" b="1" i="0" u="none" strike="noStrike" cap="none" normalizeH="0" baseline="0" dirty="0">
+                <a:ln>
+                  <a:noFill/>
+                </a:ln>
+                <a:solidFill>
+                  <a:srgbClr val="0F1115"/>
+                </a:solidFill>
+                <a:effectLst/>
+                <a:latin typeface="quote-cjk-patch"/>
+              </a:rPr>
+              <a:t>Custom Indian Traffic Sign Dataset</a:t>
+            </a:r>
+            <a:endParaRPr kumimoji="0" lang="en-US" altLang="en-US" sz="2400" b="0" i="0" u="none" strike="noStrike" cap="none" normalizeH="0" baseline="0" dirty="0">
+              <a:ln>
+                <a:noFill/>
+              </a:ln>
+              <a:solidFill>
+                <a:schemeClr val="tx1"/>
+              </a:solidFill>
+              <a:effectLst/>
+            </a:endParaRPr>
+          </a:p>
+          <a:p>
+            <a:pPr marL="0" marR="0" lvl="0" indent="0" algn="l" defTabSz="914400" rtl="0" eaLnBrk="0" fontAlgn="base" latinLnBrk="0" hangingPunct="0">
+              <a:lnSpc>
+                <a:spcPct val="100000"/>
+              </a:lnSpc>
+              <a:spcBef>
+                <a:spcPct val="0"/>
+              </a:spcBef>
+              <a:spcAft>
+                <a:spcPct val="0"/>
+              </a:spcAft>
+              <a:buClrTx/>
+              <a:buSzTx/>
+              <a:buFontTx/>
+              <a:buNone/>
+              <a:tabLst/>
+            </a:pPr>
+            <a:r>
+              <a:rPr kumimoji="0" lang="en-US" altLang="en-US" sz="2400" b="1" i="0" u="none" strike="noStrike" cap="none" normalizeH="0" baseline="0" dirty="0">
+                <a:ln>
+                  <a:noFill/>
+                </a:ln>
+                <a:solidFill>
+                  <a:srgbClr val="0F1115"/>
+                </a:solidFill>
+                <a:effectLst/>
+                <a:latin typeface="quote-cjk-patch"/>
+              </a:rPr>
+              <a:t>Dataset Statistics:</a:t>
+            </a:r>
+            <a:endParaRPr kumimoji="0" lang="en-US" altLang="en-US" sz="2400" b="0" i="0" u="none" strike="noStrike" cap="none" normalizeH="0" baseline="0" dirty="0">
+              <a:ln>
+                <a:noFill/>
+              </a:ln>
+              <a:solidFill>
+                <a:schemeClr val="tx1"/>
+              </a:solidFill>
+              <a:effectLst/>
+            </a:endParaRPr>
+          </a:p>
+          <a:p>
+            <a:pPr marL="0" marR="0" lvl="0" indent="0" algn="l" defTabSz="914400" rtl="0" eaLnBrk="0" fontAlgn="base" latinLnBrk="0" hangingPunct="0">
+              <a:lnSpc>
+                <a:spcPct val="100000"/>
+              </a:lnSpc>
+              <a:spcBef>
+                <a:spcPct val="0"/>
+              </a:spcBef>
+              <a:spcAft>
+                <a:spcPct val="0"/>
+              </a:spcAft>
+              <a:buClrTx/>
+              <a:buSzTx/>
+              <a:buFontTx/>
+              <a:buNone/>
+              <a:tabLst/>
+            </a:pPr>
+            <a:endParaRPr kumimoji="0" lang="en-US" altLang="en-US" sz="1800" b="0" i="0" u="none" strike="noStrike" cap="none" normalizeH="0" baseline="0" dirty="0">
+              <a:ln>
+                <a:noFill/>
+              </a:ln>
+              <a:solidFill>
+                <a:schemeClr val="tx1"/>
+              </a:solidFill>
+              <a:effectLst/>
+              <a:latin typeface="Arial" panose="020B0604020202020204" pitchFamily="34" charset="0"/>
+            </a:endParaRPr>
+          </a:p>
+        </p:txBody>
+      </p:sp>
+      <p:sp>
+        <p:nvSpPr>
+          <p:cNvPr id="13" name="TextBox 12">
+            <a:extLst>
+              <a:ext uri="{FF2B5EF4-FFF2-40B4-BE49-F238E27FC236}">
+                <a16:creationId xmlns:a16="http://schemas.microsoft.com/office/drawing/2014/main" id="{504039FA-F9DD-8A6A-1A7C-6E54BE28478C}"/>
+              </a:ext>
+            </a:extLst>
+          </p:cNvPr>
+          <p:cNvSpPr txBox="1"/>
+          <p:nvPr/>
+        </p:nvSpPr>
+        <p:spPr>
+          <a:xfrm>
+            <a:off x="216310" y="4801332"/>
+            <a:ext cx="8927690" cy="1292662"/>
+          </a:xfrm>
+          <a:prstGeom prst="rect">
+            <a:avLst/>
+          </a:prstGeom>
+          <a:noFill/>
+        </p:spPr>
+        <p:txBody>
+          <a:bodyPr wrap="square" rtlCol="0">
+            <a:spAutoFit/>
+          </a:bodyPr>
+          <a:lstStyle/>
+          <a:p>
+            <a:r>
+              <a:rPr lang="en-US" sz="2000" b="1" dirty="0"/>
+              <a:t>Data Sources:</a:t>
+            </a:r>
+            <a:endParaRPr lang="en-US" sz="2000" dirty="0"/>
+          </a:p>
+          <a:p>
+            <a:r>
+              <a:rPr lang="en-US" sz="2000" dirty="0"/>
+              <a:t>4,544 images (70.12%) — Real-world capture from Indian roads</a:t>
+            </a:r>
+          </a:p>
+          <a:p>
+            <a:r>
+              <a:rPr lang="en-US" sz="2000" dirty="0"/>
+              <a:t>1,936 images — Public websites ( India Mart, SlideShare</a:t>
+            </a:r>
+            <a:r>
+              <a:rPr lang="en-US" dirty="0"/>
+              <a:t>)</a:t>
+            </a:r>
+          </a:p>
+          <a:p>
+            <a:endParaRPr lang="en-IN" dirty="0"/>
+          </a:p>
+        </p:txBody>
+      </p:sp>
+    </p:spTree>
+    <p:extLst>
+      <p:ext uri="{BB962C8B-B14F-4D97-AF65-F5344CB8AC3E}">
+        <p14:creationId xmlns:p14="http://schemas.microsoft.com/office/powerpoint/2010/main" val="3131262716"/>
+      </p:ext>
+    </p:extLst>
+  </p:cSld>
+  <p:clrMapOvr>
+    <a:masterClrMapping/>
+  </p:clrMapOvr>
+</p:sld>
+</file>
+
+<file path=ppt/slides/slide13.xml><?xml version="1.0" encoding="utf-8"?>
+<p:sld xmlns:a="http://schemas.openxmlformats.org/drawingml/2006/main" xmlns:r="http://schemas.openxmlformats.org/officeDocument/2006/relationships" xmlns:p="http://schemas.openxmlformats.org/presentationml/2006/main">
+  <p:cSld>
+    <p:spTree>
+      <p:nvGrpSpPr>
+        <p:cNvPr id="1" name=""/>
+        <p:cNvGrpSpPr/>
+        <p:nvPr/>
+      </p:nvGrpSpPr>
+      <p:grpSpPr>
+        <a:xfrm>
+          <a:off x="0" y="0"/>
+          <a:ext cx="0" cy="0"/>
+          <a:chOff x="0" y="0"/>
+          <a:chExt cx="0" cy="0"/>
+        </a:xfrm>
+      </p:grpSpPr>
+      <p:pic>
+        <p:nvPicPr>
+          <p:cNvPr id="3" name="Picture 2">
+            <a:extLst>
+              <a:ext uri="{FF2B5EF4-FFF2-40B4-BE49-F238E27FC236}">
+                <a16:creationId xmlns:a16="http://schemas.microsoft.com/office/drawing/2014/main" id="{4AC34DE3-5BE5-6718-8CED-2E347D1BF842}"/>
+              </a:ext>
+            </a:extLst>
+          </p:cNvPr>
+          <p:cNvPicPr>
+            <a:picLocks noChangeAspect="1"/>
+          </p:cNvPicPr>
+          <p:nvPr/>
+        </p:nvPicPr>
+        <p:blipFill>
+          <a:blip r:embed="rId2">
+            <a:extLst>
+              <a:ext uri="{28A0092B-C50C-407E-A947-70E740481C1C}">
+                <a14:useLocalDpi xmlns:a14="http://schemas.microsoft.com/office/drawing/2010/main" val="0"/>
+              </a:ext>
+            </a:extLst>
+          </a:blip>
+          <a:stretch>
+            <a:fillRect/>
+          </a:stretch>
+        </p:blipFill>
+        <p:spPr>
+          <a:xfrm>
+            <a:off x="0" y="381000"/>
+            <a:ext cx="9144000" cy="6096000"/>
+          </a:xfrm>
+          <a:prstGeom prst="rect">
+            <a:avLst/>
+          </a:prstGeom>
+        </p:spPr>
+      </p:pic>
+    </p:spTree>
+    <p:extLst>
+      <p:ext uri="{BB962C8B-B14F-4D97-AF65-F5344CB8AC3E}">
+        <p14:creationId xmlns:p14="http://schemas.microsoft.com/office/powerpoint/2010/main" val="422212364"/>
+      </p:ext>
+    </p:extLst>
+  </p:cSld>
+  <p:clrMapOvr>
+    <a:masterClrMapping/>
+  </p:clrMapOvr>
+</p:sld>
+</file>
+
+<file path=ppt/slides/slide14.xml><?xml version="1.0" encoding="utf-8"?>
+<p:sld xmlns:a="http://schemas.openxmlformats.org/drawingml/2006/main" xmlns:r="http://schemas.openxmlformats.org/officeDocument/2006/relationships" xmlns:p="http://schemas.openxmlformats.org/presentationml/2006/main">
+  <p:cSld>
+    <p:spTree>
+      <p:nvGrpSpPr>
+        <p:cNvPr id="1" name=""/>
+        <p:cNvGrpSpPr/>
+        <p:nvPr/>
+      </p:nvGrpSpPr>
+      <p:grpSpPr>
+        <a:xfrm>
+          <a:off x="0" y="0"/>
+          <a:ext cx="0" cy="0"/>
+          <a:chOff x="0" y="0"/>
+          <a:chExt cx="0" cy="0"/>
+        </a:xfrm>
+      </p:grpSpPr>
+      <p:sp>
+        <p:nvSpPr>
           <p:cNvPr id="3" name="Text Placeholder 2">
             <a:extLst>
               <a:ext uri="{FF2B5EF4-FFF2-40B4-BE49-F238E27FC236}">
@@ -4124,7 +5525,7 @@
 </p:sld>
 </file>
 
-<file path=ppt/slides/slide11.xml><?xml version="1.0" encoding="utf-8"?>
+<file path=ppt/slides/slide15.xml><?xml version="1.0" encoding="utf-8"?>
 <p:sld xmlns:a="http://schemas.openxmlformats.org/drawingml/2006/main" xmlns:r="http://schemas.openxmlformats.org/officeDocument/2006/relationships" xmlns:p="http://schemas.openxmlformats.org/presentationml/2006/main">
   <p:cSld>
     <p:spTree>
@@ -4888,7 +6289,7 @@
 </p:sld>
 </file>
 
-<file path=ppt/slides/slide12.xml><?xml version="1.0" encoding="utf-8"?>
+<file path=ppt/slides/slide16.xml><?xml version="1.0" encoding="utf-8"?>
 <p:sld xmlns:a="http://schemas.openxmlformats.org/drawingml/2006/main" xmlns:r="http://schemas.openxmlformats.org/officeDocument/2006/relationships" xmlns:p="http://schemas.openxmlformats.org/presentationml/2006/main">
   <p:cSld>
     <p:spTree>
@@ -5800,7 +7201,7 @@
 </p:sld>
 </file>
 
-<file path=ppt/slides/slide13.xml><?xml version="1.0" encoding="utf-8"?>
+<file path=ppt/slides/slide17.xml><?xml version="1.0" encoding="utf-8"?>
 <p:sld xmlns:a="http://schemas.openxmlformats.org/drawingml/2006/main" xmlns:r="http://schemas.openxmlformats.org/officeDocument/2006/relationships" xmlns:p="http://schemas.openxmlformats.org/presentationml/2006/main">
   <p:cSld>
     <p:spTree>
@@ -6515,7 +7916,154 @@
 </p:sld>
 </file>
 
-<file path=ppt/slides/slide14.xml><?xml version="1.0" encoding="utf-8"?>
+<file path=ppt/slides/slide18.xml><?xml version="1.0" encoding="utf-8"?>
+<p:sld xmlns:a="http://schemas.openxmlformats.org/drawingml/2006/main" xmlns:r="http://schemas.openxmlformats.org/officeDocument/2006/relationships" xmlns:p="http://schemas.openxmlformats.org/presentationml/2006/main">
+  <p:cSld>
+    <p:spTree>
+      <p:nvGrpSpPr>
+        <p:cNvPr id="1" name=""/>
+        <p:cNvGrpSpPr/>
+        <p:nvPr/>
+      </p:nvGrpSpPr>
+      <p:grpSpPr>
+        <a:xfrm>
+          <a:off x="0" y="0"/>
+          <a:ext cx="0" cy="0"/>
+          <a:chOff x="0" y="0"/>
+          <a:chExt cx="0" cy="0"/>
+        </a:xfrm>
+      </p:grpSpPr>
+      <p:pic>
+        <p:nvPicPr>
+          <p:cNvPr id="2" name="Picture 1">
+            <a:extLst>
+              <a:ext uri="{FF2B5EF4-FFF2-40B4-BE49-F238E27FC236}">
+                <a16:creationId xmlns:a16="http://schemas.microsoft.com/office/drawing/2014/main" id="{9D5A95E5-D67F-0633-8681-6073E5F0ED4E}"/>
+              </a:ext>
+            </a:extLst>
+          </p:cNvPr>
+          <p:cNvPicPr>
+            <a:picLocks noChangeAspect="1"/>
+          </p:cNvPicPr>
+          <p:nvPr/>
+        </p:nvPicPr>
+        <p:blipFill>
+          <a:blip r:embed="rId2">
+            <a:extLst>
+              <a:ext uri="{28A0092B-C50C-407E-A947-70E740481C1C}">
+                <a14:useLocalDpi xmlns:a14="http://schemas.microsoft.com/office/drawing/2010/main" val="0"/>
+              </a:ext>
+            </a:extLst>
+          </a:blip>
+          <a:srcRect/>
+          <a:stretch>
+            <a:fillRect/>
+          </a:stretch>
+        </p:blipFill>
+        <p:spPr bwMode="auto">
+          <a:xfrm>
+            <a:off x="1" y="943896"/>
+            <a:ext cx="4483509" cy="3405997"/>
+          </a:xfrm>
+          <a:prstGeom prst="rect">
+            <a:avLst/>
+          </a:prstGeom>
+          <a:noFill/>
+          <a:ln>
+            <a:noFill/>
+          </a:ln>
+        </p:spPr>
+      </p:pic>
+      <p:pic>
+        <p:nvPicPr>
+          <p:cNvPr id="3" name="Picture 2">
+            <a:extLst>
+              <a:ext uri="{FF2B5EF4-FFF2-40B4-BE49-F238E27FC236}">
+                <a16:creationId xmlns:a16="http://schemas.microsoft.com/office/drawing/2014/main" id="{6ABC8291-8615-0F05-DE21-6673AF921099}"/>
+              </a:ext>
+            </a:extLst>
+          </p:cNvPr>
+          <p:cNvPicPr>
+            <a:picLocks noChangeAspect="1"/>
+          </p:cNvPicPr>
+          <p:nvPr/>
+        </p:nvPicPr>
+        <p:blipFill>
+          <a:blip r:embed="rId3">
+            <a:extLst>
+              <a:ext uri="{28A0092B-C50C-407E-A947-70E740481C1C}">
+                <a14:useLocalDpi xmlns:a14="http://schemas.microsoft.com/office/drawing/2010/main" val="0"/>
+              </a:ext>
+            </a:extLst>
+          </a:blip>
+          <a:srcRect/>
+          <a:stretch>
+            <a:fillRect/>
+          </a:stretch>
+        </p:blipFill>
+        <p:spPr bwMode="auto">
+          <a:xfrm>
+            <a:off x="4572000" y="943896"/>
+            <a:ext cx="4404851" cy="3405997"/>
+          </a:xfrm>
+          <a:prstGeom prst="rect">
+            <a:avLst/>
+          </a:prstGeom>
+          <a:noFill/>
+          <a:ln>
+            <a:noFill/>
+          </a:ln>
+        </p:spPr>
+      </p:pic>
+      <p:sp>
+        <p:nvSpPr>
+          <p:cNvPr id="4" name="TextBox 3">
+            <a:extLst>
+              <a:ext uri="{FF2B5EF4-FFF2-40B4-BE49-F238E27FC236}">
+                <a16:creationId xmlns:a16="http://schemas.microsoft.com/office/drawing/2014/main" id="{E5BB1FC6-2554-05D8-E961-8E22CF454AC0}"/>
+              </a:ext>
+            </a:extLst>
+          </p:cNvPr>
+          <p:cNvSpPr txBox="1"/>
+          <p:nvPr/>
+        </p:nvSpPr>
+        <p:spPr>
+          <a:xfrm>
+            <a:off x="1179871" y="5299587"/>
+            <a:ext cx="6764594" cy="369332"/>
+          </a:xfrm>
+          <a:prstGeom prst="rect">
+            <a:avLst/>
+          </a:prstGeom>
+          <a:noFill/>
+        </p:spPr>
+        <p:txBody>
+          <a:bodyPr wrap="square" rtlCol="0">
+            <a:spAutoFit/>
+          </a:bodyPr>
+          <a:lstStyle/>
+          <a:p>
+            <a:r>
+              <a:rPr lang="en-IN" dirty="0"/>
+              <a:t>Graphs for two different images about their pixel count</a:t>
+            </a:r>
+          </a:p>
+        </p:txBody>
+      </p:sp>
+    </p:spTree>
+    <p:extLst>
+      <p:ext uri="{BB962C8B-B14F-4D97-AF65-F5344CB8AC3E}">
+        <p14:creationId xmlns:p14="http://schemas.microsoft.com/office/powerpoint/2010/main" val="138873811"/>
+      </p:ext>
+    </p:extLst>
+  </p:cSld>
+  <p:clrMapOvr>
+    <a:masterClrMapping/>
+  </p:clrMapOvr>
+</p:sld>
+</file>
+
+<file path=ppt/slides/slide19.xml><?xml version="1.0" encoding="utf-8"?>
 <p:sld xmlns:a="http://schemas.openxmlformats.org/drawingml/2006/main" xmlns:r="http://schemas.openxmlformats.org/officeDocument/2006/relationships" xmlns:p="http://schemas.openxmlformats.org/presentationml/2006/main">
   <p:cSld>
     <p:spTree>
@@ -6720,134 +8268,6 @@
     <p:extLst>
       <p:ext uri="{BB962C8B-B14F-4D97-AF65-F5344CB8AC3E}">
         <p14:creationId xmlns:p14="http://schemas.microsoft.com/office/powerpoint/2010/main" val="548195034"/>
-      </p:ext>
-    </p:extLst>
-  </p:cSld>
-  <p:clrMapOvr>
-    <a:masterClrMapping/>
-  </p:clrMapOvr>
-</p:sld>
-</file>
-
-<file path=ppt/slides/slide15.xml><?xml version="1.0" encoding="utf-8"?>
-<p:sld xmlns:a="http://schemas.openxmlformats.org/drawingml/2006/main" xmlns:r="http://schemas.openxmlformats.org/officeDocument/2006/relationships" xmlns:p="http://schemas.openxmlformats.org/presentationml/2006/main">
-  <p:cSld>
-    <p:spTree>
-      <p:nvGrpSpPr>
-        <p:cNvPr id="1" name=""/>
-        <p:cNvGrpSpPr/>
-        <p:nvPr/>
-      </p:nvGrpSpPr>
-      <p:grpSpPr>
-        <a:xfrm>
-          <a:off x="0" y="0"/>
-          <a:ext cx="0" cy="0"/>
-          <a:chOff x="0" y="0"/>
-          <a:chExt cx="0" cy="0"/>
-        </a:xfrm>
-      </p:grpSpPr>
-      <p:sp>
-        <p:nvSpPr>
-          <p:cNvPr id="108" name="TextShape 1"/>
-          <p:cNvSpPr txBox="1"/>
-          <p:nvPr/>
-        </p:nvSpPr>
-        <p:spPr>
-          <a:xfrm>
-            <a:off x="1297577" y="2821578"/>
-            <a:ext cx="6705599" cy="1410788"/>
-          </a:xfrm>
-          <a:prstGeom prst="rect">
-            <a:avLst/>
-          </a:prstGeom>
-          <a:noFill/>
-          <a:ln w="9360">
-            <a:noFill/>
-          </a:ln>
-        </p:spPr>
-        <p:txBody>
-          <a:bodyPr anchor="ctr">
-            <a:noAutofit/>
-          </a:bodyPr>
-          <a:lstStyle/>
-          <a:p>
-            <a:pPr algn="ctr">
-              <a:lnSpc>
-                <a:spcPct val="100000"/>
-              </a:lnSpc>
-            </a:pPr>
-            <a:r>
-              <a:rPr lang="en" sz="5400" dirty="0">
-                <a:latin typeface="Times New Roman" panose="02020603050405020304" pitchFamily="18" charset="0"/>
-                <a:cs typeface="Times New Roman" panose="02020603050405020304" pitchFamily="18" charset="0"/>
-              </a:rPr>
-              <a:t>Thank You</a:t>
-            </a:r>
-            <a:endParaRPr lang="en-US" sz="5400" b="0" strike="noStrike" spc="-1" dirty="0">
-              <a:solidFill>
-                <a:srgbClr val="000000"/>
-              </a:solidFill>
-              <a:latin typeface="Times New Roman" panose="02020603050405020304" pitchFamily="18" charset="0"/>
-              <a:cs typeface="Times New Roman" panose="02020603050405020304" pitchFamily="18" charset="0"/>
-            </a:endParaRPr>
-          </a:p>
-        </p:txBody>
-      </p:sp>
-      <p:sp>
-        <p:nvSpPr>
-          <p:cNvPr id="110" name="TextShape 3"/>
-          <p:cNvSpPr txBox="1"/>
-          <p:nvPr/>
-        </p:nvSpPr>
-        <p:spPr>
-          <a:xfrm>
-            <a:off x="6553080" y="6356520"/>
-            <a:ext cx="2133360" cy="364680"/>
-          </a:xfrm>
-          <a:prstGeom prst="rect">
-            <a:avLst/>
-          </a:prstGeom>
-          <a:noFill/>
-          <a:ln>
-            <a:noFill/>
-          </a:ln>
-        </p:spPr>
-        <p:txBody>
-          <a:bodyPr anchor="ctr">
-            <a:noAutofit/>
-          </a:bodyPr>
-          <a:lstStyle/>
-          <a:p>
-            <a:pPr algn="r">
-              <a:lnSpc>
-                <a:spcPct val="100000"/>
-              </a:lnSpc>
-            </a:pPr>
-            <a:fld id="{4D4FEEEE-7AC5-48A9-86F4-13448BE87B58}" type="slidenum">
-              <a:rPr lang="en-US" sz="1200" b="1" strike="noStrike" spc="-1">
-                <a:solidFill>
-                  <a:srgbClr val="000000"/>
-                </a:solidFill>
-                <a:latin typeface="Calibri"/>
-                <a:ea typeface="MS PGothic"/>
-              </a:rPr>
-              <a:pPr algn="r">
-                <a:lnSpc>
-                  <a:spcPct val="100000"/>
-                </a:lnSpc>
-              </a:pPr>
-              <a:t>15</a:t>
-            </a:fld>
-            <a:endParaRPr lang="en-GB" sz="1200" b="0" strike="noStrike" spc="-1">
-              <a:latin typeface="Times New Roman"/>
-            </a:endParaRPr>
-          </a:p>
-        </p:txBody>
-      </p:sp>
-    </p:spTree>
-    <p:extLst>
-      <p:ext uri="{BB962C8B-B14F-4D97-AF65-F5344CB8AC3E}">
-        <p14:creationId xmlns:p14="http://schemas.microsoft.com/office/powerpoint/2010/main" val="2834479809"/>
       </p:ext>
     </p:extLst>
   </p:cSld>
@@ -7669,6 +9089,134 @@
 </p:sld>
 </file>
 
+<file path=ppt/slides/slide20.xml><?xml version="1.0" encoding="utf-8"?>
+<p:sld xmlns:a="http://schemas.openxmlformats.org/drawingml/2006/main" xmlns:r="http://schemas.openxmlformats.org/officeDocument/2006/relationships" xmlns:p="http://schemas.openxmlformats.org/presentationml/2006/main">
+  <p:cSld>
+    <p:spTree>
+      <p:nvGrpSpPr>
+        <p:cNvPr id="1" name=""/>
+        <p:cNvGrpSpPr/>
+        <p:nvPr/>
+      </p:nvGrpSpPr>
+      <p:grpSpPr>
+        <a:xfrm>
+          <a:off x="0" y="0"/>
+          <a:ext cx="0" cy="0"/>
+          <a:chOff x="0" y="0"/>
+          <a:chExt cx="0" cy="0"/>
+        </a:xfrm>
+      </p:grpSpPr>
+      <p:sp>
+        <p:nvSpPr>
+          <p:cNvPr id="108" name="TextShape 1"/>
+          <p:cNvSpPr txBox="1"/>
+          <p:nvPr/>
+        </p:nvSpPr>
+        <p:spPr>
+          <a:xfrm>
+            <a:off x="1297577" y="2821578"/>
+            <a:ext cx="6705599" cy="1410788"/>
+          </a:xfrm>
+          <a:prstGeom prst="rect">
+            <a:avLst/>
+          </a:prstGeom>
+          <a:noFill/>
+          <a:ln w="9360">
+            <a:noFill/>
+          </a:ln>
+        </p:spPr>
+        <p:txBody>
+          <a:bodyPr anchor="ctr">
+            <a:noAutofit/>
+          </a:bodyPr>
+          <a:lstStyle/>
+          <a:p>
+            <a:pPr algn="ctr">
+              <a:lnSpc>
+                <a:spcPct val="100000"/>
+              </a:lnSpc>
+            </a:pPr>
+            <a:r>
+              <a:rPr lang="en" sz="5400" dirty="0">
+                <a:latin typeface="Times New Roman" panose="02020603050405020304" pitchFamily="18" charset="0"/>
+                <a:cs typeface="Times New Roman" panose="02020603050405020304" pitchFamily="18" charset="0"/>
+              </a:rPr>
+              <a:t>Thank You</a:t>
+            </a:r>
+            <a:endParaRPr lang="en-US" sz="5400" b="0" strike="noStrike" spc="-1" dirty="0">
+              <a:solidFill>
+                <a:srgbClr val="000000"/>
+              </a:solidFill>
+              <a:latin typeface="Times New Roman" panose="02020603050405020304" pitchFamily="18" charset="0"/>
+              <a:cs typeface="Times New Roman" panose="02020603050405020304" pitchFamily="18" charset="0"/>
+            </a:endParaRPr>
+          </a:p>
+        </p:txBody>
+      </p:sp>
+      <p:sp>
+        <p:nvSpPr>
+          <p:cNvPr id="110" name="TextShape 3"/>
+          <p:cNvSpPr txBox="1"/>
+          <p:nvPr/>
+        </p:nvSpPr>
+        <p:spPr>
+          <a:xfrm>
+            <a:off x="6553080" y="6356520"/>
+            <a:ext cx="2133360" cy="364680"/>
+          </a:xfrm>
+          <a:prstGeom prst="rect">
+            <a:avLst/>
+          </a:prstGeom>
+          <a:noFill/>
+          <a:ln>
+            <a:noFill/>
+          </a:ln>
+        </p:spPr>
+        <p:txBody>
+          <a:bodyPr anchor="ctr">
+            <a:noAutofit/>
+          </a:bodyPr>
+          <a:lstStyle/>
+          <a:p>
+            <a:pPr algn="r">
+              <a:lnSpc>
+                <a:spcPct val="100000"/>
+              </a:lnSpc>
+            </a:pPr>
+            <a:fld id="{4D4FEEEE-7AC5-48A9-86F4-13448BE87B58}" type="slidenum">
+              <a:rPr lang="en-US" sz="1200" b="1" strike="noStrike" spc="-1">
+                <a:solidFill>
+                  <a:srgbClr val="000000"/>
+                </a:solidFill>
+                <a:latin typeface="Calibri"/>
+                <a:ea typeface="MS PGothic"/>
+              </a:rPr>
+              <a:pPr algn="r">
+                <a:lnSpc>
+                  <a:spcPct val="100000"/>
+                </a:lnSpc>
+              </a:pPr>
+              <a:t>20</a:t>
+            </a:fld>
+            <a:endParaRPr lang="en-GB" sz="1200" b="0" strike="noStrike" spc="-1">
+              <a:latin typeface="Times New Roman"/>
+            </a:endParaRPr>
+          </a:p>
+        </p:txBody>
+      </p:sp>
+    </p:spTree>
+    <p:extLst>
+      <p:ext uri="{BB962C8B-B14F-4D97-AF65-F5344CB8AC3E}">
+        <p14:creationId xmlns:p14="http://schemas.microsoft.com/office/powerpoint/2010/main" val="2834479809"/>
+      </p:ext>
+    </p:extLst>
+  </p:cSld>
+  <p:clrMapOvr>
+    <a:masterClrMapping/>
+  </p:clrMapOvr>
+</p:sld>
+</file>
+
 <file path=ppt/slides/slide3.xml><?xml version="1.0" encoding="utf-8"?>
 <p:sld xmlns:a="http://schemas.openxmlformats.org/drawingml/2006/main" xmlns:r="http://schemas.openxmlformats.org/officeDocument/2006/relationships" xmlns:p="http://schemas.openxmlformats.org/presentationml/2006/main">
   <p:cSld>
@@ -7866,6 +9414,72 @@
 </file>
 
 <file path=ppt/slides/slide4.xml><?xml version="1.0" encoding="utf-8"?>
+<p:sld xmlns:a="http://schemas.openxmlformats.org/drawingml/2006/main" xmlns:r="http://schemas.openxmlformats.org/officeDocument/2006/relationships" xmlns:p="http://schemas.openxmlformats.org/presentationml/2006/main">
+  <p:cSld>
+    <p:spTree>
+      <p:nvGrpSpPr>
+        <p:cNvPr id="1" name=""/>
+        <p:cNvGrpSpPr/>
+        <p:nvPr/>
+      </p:nvGrpSpPr>
+      <p:grpSpPr>
+        <a:xfrm>
+          <a:off x="0" y="0"/>
+          <a:ext cx="0" cy="0"/>
+          <a:chOff x="0" y="0"/>
+          <a:chExt cx="0" cy="0"/>
+        </a:xfrm>
+      </p:grpSpPr>
+      <p:pic>
+        <p:nvPicPr>
+          <p:cNvPr id="3" name="Picture 2">
+            <a:extLst>
+              <a:ext uri="{FF2B5EF4-FFF2-40B4-BE49-F238E27FC236}">
+                <a16:creationId xmlns:a16="http://schemas.microsoft.com/office/drawing/2014/main" id="{4221EAD9-6097-09D2-DF74-167C2EAE0209}"/>
+              </a:ext>
+            </a:extLst>
+          </p:cNvPr>
+          <p:cNvPicPr>
+            <a:picLocks noChangeAspect="1"/>
+          </p:cNvPicPr>
+          <p:nvPr/>
+        </p:nvPicPr>
+        <p:blipFill>
+          <a:blip r:embed="rId2">
+            <a:extLst>
+              <a:ext uri="{28A0092B-C50C-407E-A947-70E740481C1C}">
+                <a14:useLocalDpi xmlns:a14="http://schemas.microsoft.com/office/drawing/2010/main" val="0"/>
+              </a:ext>
+            </a:extLst>
+          </a:blip>
+          <a:stretch>
+            <a:fillRect/>
+          </a:stretch>
+        </p:blipFill>
+        <p:spPr>
+          <a:xfrm>
+            <a:off x="0" y="381000"/>
+            <a:ext cx="9144000" cy="6096000"/>
+          </a:xfrm>
+          <a:prstGeom prst="rect">
+            <a:avLst/>
+          </a:prstGeom>
+        </p:spPr>
+      </p:pic>
+    </p:spTree>
+    <p:extLst>
+      <p:ext uri="{BB962C8B-B14F-4D97-AF65-F5344CB8AC3E}">
+        <p14:creationId xmlns:p14="http://schemas.microsoft.com/office/powerpoint/2010/main" val="1177224598"/>
+      </p:ext>
+    </p:extLst>
+  </p:cSld>
+  <p:clrMapOvr>
+    <a:masterClrMapping/>
+  </p:clrMapOvr>
+</p:sld>
+</file>
+
+<file path=ppt/slides/slide5.xml><?xml version="1.0" encoding="utf-8"?>
 <p:sld xmlns:a="http://schemas.openxmlformats.org/drawingml/2006/main" xmlns:r="http://schemas.openxmlformats.org/officeDocument/2006/relationships" xmlns:p="http://schemas.openxmlformats.org/presentationml/2006/main">
   <p:cSld>
     <p:spTree>
@@ -8583,7 +10197,73 @@
 </p:sld>
 </file>
 
-<file path=ppt/slides/slide5.xml><?xml version="1.0" encoding="utf-8"?>
+<file path=ppt/slides/slide6.xml><?xml version="1.0" encoding="utf-8"?>
+<p:sld xmlns:a="http://schemas.openxmlformats.org/drawingml/2006/main" xmlns:r="http://schemas.openxmlformats.org/officeDocument/2006/relationships" xmlns:p="http://schemas.openxmlformats.org/presentationml/2006/main">
+  <p:cSld>
+    <p:spTree>
+      <p:nvGrpSpPr>
+        <p:cNvPr id="1" name=""/>
+        <p:cNvGrpSpPr/>
+        <p:nvPr/>
+      </p:nvGrpSpPr>
+      <p:grpSpPr>
+        <a:xfrm>
+          <a:off x="0" y="0"/>
+          <a:ext cx="0" cy="0"/>
+          <a:chOff x="0" y="0"/>
+          <a:chExt cx="0" cy="0"/>
+        </a:xfrm>
+      </p:grpSpPr>
+      <p:pic>
+        <p:nvPicPr>
+          <p:cNvPr id="3" name="Picture 2">
+            <a:extLst>
+              <a:ext uri="{FF2B5EF4-FFF2-40B4-BE49-F238E27FC236}">
+                <a16:creationId xmlns:a16="http://schemas.microsoft.com/office/drawing/2014/main" id="{EFE2FA82-16A4-7914-5EA0-57D6EDCC69FB}"/>
+              </a:ext>
+            </a:extLst>
+          </p:cNvPr>
+          <p:cNvPicPr>
+            <a:picLocks noChangeAspect="1"/>
+          </p:cNvPicPr>
+          <p:nvPr/>
+        </p:nvPicPr>
+        <p:blipFill>
+          <a:blip r:embed="rId2">
+            <a:extLst>
+              <a:ext uri="{28A0092B-C50C-407E-A947-70E740481C1C}">
+                <a14:useLocalDpi xmlns:a14="http://schemas.microsoft.com/office/drawing/2010/main" val="0"/>
+              </a:ext>
+            </a:extLst>
+          </a:blip>
+          <a:stretch>
+            <a:fillRect/>
+          </a:stretch>
+        </p:blipFill>
+        <p:spPr>
+          <a:xfrm>
+            <a:off x="0" y="381000"/>
+            <a:ext cx="9144000" cy="6096000"/>
+          </a:xfrm>
+          <a:prstGeom prst="rect">
+            <a:avLst/>
+          </a:prstGeom>
+        </p:spPr>
+      </p:pic>
+    </p:spTree>
+    <p:extLst>
+      <p:ext uri="{BB962C8B-B14F-4D97-AF65-F5344CB8AC3E}">
+        <p14:creationId xmlns:p14="http://schemas.microsoft.com/office/powerpoint/2010/main" val="3171255946"/>
+      </p:ext>
+    </p:extLst>
+  </p:cSld>
+  <p:clrMapOvr>
+    <a:masterClrMapping/>
+  </p:clrMapOvr>
+</p:sld>
+</file>
+
+<file path=ppt/slides/slide7.xml><?xml version="1.0" encoding="utf-8"?>
 <p:sld xmlns:a="http://schemas.openxmlformats.org/drawingml/2006/main" xmlns:r="http://schemas.openxmlformats.org/officeDocument/2006/relationships" xmlns:p="http://schemas.openxmlformats.org/presentationml/2006/main">
   <p:cSld>
     <p:spTree>
@@ -8804,7 +10484,7 @@
 </p:sld>
 </file>
 
-<file path=ppt/slides/slide6.xml><?xml version="1.0" encoding="utf-8"?>
+<file path=ppt/slides/slide8.xml><?xml version="1.0" encoding="utf-8"?>
 <p:sld xmlns:a="http://schemas.openxmlformats.org/drawingml/2006/main" xmlns:r="http://schemas.openxmlformats.org/officeDocument/2006/relationships" xmlns:p="http://schemas.openxmlformats.org/presentationml/2006/main">
   <p:cSld>
     <p:spTree>
@@ -9029,7 +10709,7 @@
 </p:sld>
 </file>
 
-<file path=ppt/slides/slide7.xml><?xml version="1.0" encoding="utf-8"?>
+<file path=ppt/slides/slide9.xml><?xml version="1.0" encoding="utf-8"?>
 <p:sld xmlns:a="http://schemas.openxmlformats.org/drawingml/2006/main" xmlns:r="http://schemas.openxmlformats.org/officeDocument/2006/relationships" xmlns:p="http://schemas.openxmlformats.org/presentationml/2006/main">
   <p:cSld>
     <p:spTree>
@@ -9183,1270 +10863,6 @@
     <p:extLst>
       <p:ext uri="{BB962C8B-B14F-4D97-AF65-F5344CB8AC3E}">
         <p14:creationId xmlns:p14="http://schemas.microsoft.com/office/powerpoint/2010/main" val="2529073939"/>
-      </p:ext>
-    </p:extLst>
-  </p:cSld>
-  <p:clrMapOvr>
-    <a:masterClrMapping/>
-  </p:clrMapOvr>
-</p:sld>
-</file>
-
-<file path=ppt/slides/slide8.xml><?xml version="1.0" encoding="utf-8"?>
-<p:sld xmlns:a="http://schemas.openxmlformats.org/drawingml/2006/main" xmlns:r="http://schemas.openxmlformats.org/officeDocument/2006/relationships" xmlns:p="http://schemas.openxmlformats.org/presentationml/2006/main">
-  <p:cSld>
-    <p:spTree>
-      <p:nvGrpSpPr>
-        <p:cNvPr id="1" name=""/>
-        <p:cNvGrpSpPr/>
-        <p:nvPr/>
-      </p:nvGrpSpPr>
-      <p:grpSpPr>
-        <a:xfrm>
-          <a:off x="0" y="0"/>
-          <a:ext cx="0" cy="0"/>
-          <a:chOff x="0" y="0"/>
-          <a:chExt cx="0" cy="0"/>
-        </a:xfrm>
-      </p:grpSpPr>
-      <p:sp>
-        <p:nvSpPr>
-          <p:cNvPr id="2" name="Title 1">
-            <a:extLst>
-              <a:ext uri="{FF2B5EF4-FFF2-40B4-BE49-F238E27FC236}">
-                <a16:creationId xmlns:a16="http://schemas.microsoft.com/office/drawing/2014/main" id="{0E0A953C-1ED2-6CC3-6D87-C58BB814EBCB}"/>
-              </a:ext>
-            </a:extLst>
-          </p:cNvPr>
-          <p:cNvSpPr>
-            <a:spLocks noGrp="1"/>
-          </p:cNvSpPr>
-          <p:nvPr>
-            <p:ph type="title"/>
-          </p:nvPr>
-        </p:nvSpPr>
-        <p:spPr>
-          <a:xfrm>
-            <a:off x="-1" y="0"/>
-            <a:ext cx="5683045" cy="1160206"/>
-          </a:xfrm>
-        </p:spPr>
-        <p:txBody>
-          <a:bodyPr/>
-          <a:lstStyle/>
-          <a:p>
-            <a:r>
-              <a:rPr lang="en-US" sz="3000" b="1" dirty="0"/>
-              <a:t>Proposed Solution - Method Used (CNN / RMR-CNN)</a:t>
-            </a:r>
-            <a:br>
-              <a:rPr lang="en-US" sz="3000" b="1" dirty="0"/>
-            </a:br>
-            <a:endParaRPr lang="en-IN" sz="3000" dirty="0"/>
-          </a:p>
-        </p:txBody>
-      </p:sp>
-      <p:sp>
-        <p:nvSpPr>
-          <p:cNvPr id="3" name="Text Placeholder 2">
-            <a:extLst>
-              <a:ext uri="{FF2B5EF4-FFF2-40B4-BE49-F238E27FC236}">
-                <a16:creationId xmlns:a16="http://schemas.microsoft.com/office/drawing/2014/main" id="{CC3FA738-79C3-D34F-A077-372BBBC8D6B1}"/>
-              </a:ext>
-            </a:extLst>
-          </p:cNvPr>
-          <p:cNvSpPr>
-            <a:spLocks noGrp="1"/>
-          </p:cNvSpPr>
-          <p:nvPr>
-            <p:ph type="body"/>
-          </p:nvPr>
-        </p:nvSpPr>
-        <p:spPr>
-          <a:xfrm>
-            <a:off x="-1" y="1061884"/>
-            <a:ext cx="9075175" cy="5633884"/>
-          </a:xfrm>
-        </p:spPr>
-        <p:txBody>
-          <a:bodyPr>
-            <a:normAutofit fontScale="92500" lnSpcReduction="10000"/>
-          </a:bodyPr>
-          <a:lstStyle/>
-          <a:p>
-            <a:pPr marL="457200" indent="-457200">
-              <a:buFont typeface="Arial" panose="020B0604020202020204" pitchFamily="34" charset="0"/>
-              <a:buChar char="•"/>
-            </a:pPr>
-            <a:r>
-              <a:rPr lang="en-IN" sz="3100" b="1" dirty="0"/>
-              <a:t>Refined Mask R-CNN (RMR-CNN) Architecture</a:t>
-            </a:r>
-            <a:endParaRPr lang="en-IN" sz="3100" dirty="0"/>
-          </a:p>
-          <a:p>
-            <a:pPr marL="342900" indent="-342900">
-              <a:buFont typeface="Arial" panose="020B0604020202020204" pitchFamily="34" charset="0"/>
-              <a:buChar char="•"/>
-            </a:pPr>
-            <a:r>
-              <a:rPr lang="en-IN" sz="2300" b="1" dirty="0"/>
-              <a:t>Why Mask R-CNN?</a:t>
-            </a:r>
-            <a:endParaRPr lang="en-IN" sz="2300" dirty="0"/>
-          </a:p>
-          <a:p>
-            <a:pPr marL="342900" indent="-342900">
-              <a:buFont typeface="Arial" panose="020B0604020202020204" pitchFamily="34" charset="0"/>
-              <a:buChar char="•"/>
-            </a:pPr>
-            <a:r>
-              <a:rPr lang="en-IN" sz="2300" dirty="0"/>
-              <a:t>Faster R-CNN provides only bounding boxes (includes both object and background pixels)</a:t>
-            </a:r>
-          </a:p>
-          <a:p>
-            <a:pPr marL="342900" indent="-342900">
-              <a:buFont typeface="Arial" panose="020B0604020202020204" pitchFamily="34" charset="0"/>
-              <a:buChar char="•"/>
-            </a:pPr>
-            <a:r>
-              <a:rPr lang="en-IN" sz="2300" b="1" dirty="0"/>
-              <a:t>Mask R-CNN</a:t>
-            </a:r>
-            <a:r>
-              <a:rPr lang="en-IN" sz="2300" dirty="0"/>
-              <a:t> outputs a binary mask to determine whether a pixel belongs to a particular object → higher precision</a:t>
-            </a:r>
-          </a:p>
-          <a:p>
-            <a:pPr marL="342900" indent="-342900">
-              <a:buFont typeface="Arial" panose="020B0604020202020204" pitchFamily="34" charset="0"/>
-              <a:buChar char="•"/>
-            </a:pPr>
-            <a:r>
-              <a:rPr lang="en-IN" sz="2300" b="1" dirty="0"/>
-              <a:t>Our Refinements (RMR-CNN):</a:t>
-            </a:r>
-            <a:endParaRPr lang="en-IN" sz="2300" dirty="0"/>
-          </a:p>
-          <a:p>
-            <a:pPr marL="342900" indent="-342900">
-              <a:buFont typeface="Arial" panose="020B0604020202020204" pitchFamily="34" charset="0"/>
-              <a:buChar char="•"/>
-            </a:pPr>
-            <a:r>
-              <a:rPr lang="en-IN" sz="2300" b="1" dirty="0"/>
-              <a:t>Architectural Improvements</a:t>
-            </a:r>
-            <a:endParaRPr lang="en-IN" sz="2300" dirty="0"/>
-          </a:p>
-          <a:p>
-            <a:pPr marL="342900" lvl="1" indent="-342900">
-              <a:buFont typeface="Arial" panose="020B0604020202020204" pitchFamily="34" charset="0"/>
-              <a:buChar char="•"/>
-            </a:pPr>
-            <a:r>
-              <a:rPr lang="en-IN" sz="2300" dirty="0"/>
-              <a:t>Enhanced feature extraction layers</a:t>
-            </a:r>
-          </a:p>
-          <a:p>
-            <a:pPr marL="342900" lvl="1" indent="-342900">
-              <a:buFont typeface="Arial" panose="020B0604020202020204" pitchFamily="34" charset="0"/>
-              <a:buChar char="•"/>
-            </a:pPr>
-            <a:r>
-              <a:rPr lang="en-IN" sz="2300" dirty="0"/>
-              <a:t>Optimized region proposal network</a:t>
-            </a:r>
-          </a:p>
-          <a:p>
-            <a:pPr marL="342900" indent="-342900">
-              <a:buFont typeface="Arial" panose="020B0604020202020204" pitchFamily="34" charset="0"/>
-              <a:buChar char="•"/>
-            </a:pPr>
-            <a:r>
-              <a:rPr lang="en-IN" sz="2300" b="1" dirty="0"/>
-              <a:t>Parameter Tuning</a:t>
-            </a:r>
-            <a:endParaRPr lang="en-IN" sz="2300" dirty="0"/>
-          </a:p>
-          <a:p>
-            <a:pPr marL="342900" lvl="1" indent="-342900">
-              <a:buFont typeface="Arial" panose="020B0604020202020204" pitchFamily="34" charset="0"/>
-              <a:buChar char="•"/>
-            </a:pPr>
-            <a:r>
-              <a:rPr lang="en-IN" sz="2300" dirty="0"/>
-              <a:t>Adjusted parametric values to adapt Mask R-CNN to Indian traffic sign requirements</a:t>
-            </a:r>
-          </a:p>
-          <a:p>
-            <a:pPr marL="342900" indent="-342900">
-              <a:buFont typeface="Arial" panose="020B0604020202020204" pitchFamily="34" charset="0"/>
-              <a:buChar char="•"/>
-            </a:pPr>
-            <a:r>
-              <a:rPr lang="en-IN" sz="2300" b="1" dirty="0"/>
-              <a:t>Data Augmentation</a:t>
-            </a:r>
-            <a:endParaRPr lang="en-IN" sz="2300" dirty="0"/>
-          </a:p>
-          <a:p>
-            <a:pPr marL="342900" lvl="1" indent="-342900">
-              <a:buFont typeface="Arial" panose="020B0604020202020204" pitchFamily="34" charset="0"/>
-              <a:buChar char="•"/>
-            </a:pPr>
-            <a:r>
-              <a:rPr lang="en-IN" sz="2300" dirty="0"/>
-              <a:t>Scaling, rotation, lighting variation simulation</a:t>
-            </a:r>
-          </a:p>
-          <a:p>
-            <a:pPr marL="342900" indent="-342900">
-              <a:buFont typeface="Arial" panose="020B0604020202020204" pitchFamily="34" charset="0"/>
-              <a:buChar char="•"/>
-            </a:pPr>
-            <a:r>
-              <a:rPr lang="en-IN" sz="2300" b="1" dirty="0"/>
-              <a:t>Pre-processing Enhancements</a:t>
-            </a:r>
-            <a:r>
-              <a:rPr lang="en-IN" sz="2300" dirty="0"/>
-              <a:t> (3 key steps):</a:t>
-            </a:r>
-          </a:p>
-          <a:p>
-            <a:pPr marL="342900" lvl="1" indent="-342900">
-              <a:buFont typeface="Arial" panose="020B0604020202020204" pitchFamily="34" charset="0"/>
-              <a:buChar char="•"/>
-            </a:pPr>
-            <a:r>
-              <a:rPr lang="en-IN" sz="2300" dirty="0"/>
-              <a:t>Shape detection (triangles, rectangles, circles)</a:t>
-            </a:r>
-          </a:p>
-          <a:p>
-            <a:pPr marL="342900" lvl="1" indent="-342900">
-              <a:buFont typeface="Arial" panose="020B0604020202020204" pitchFamily="34" charset="0"/>
-              <a:buChar char="•"/>
-            </a:pPr>
-            <a:r>
-              <a:rPr lang="en-IN" sz="2300" dirty="0"/>
-              <a:t>Region of Interest (ROI) extraction</a:t>
-            </a:r>
-          </a:p>
-          <a:p>
-            <a:pPr marL="342900" lvl="1" indent="-342900">
-              <a:buFont typeface="Arial" panose="020B0604020202020204" pitchFamily="34" charset="0"/>
-              <a:buChar char="•"/>
-            </a:pPr>
-            <a:r>
-              <a:rPr lang="en-IN" sz="2300" dirty="0" err="1"/>
-              <a:t>Color</a:t>
-            </a:r>
-            <a:r>
-              <a:rPr lang="en-IN" sz="2300" dirty="0"/>
-              <a:t> probability analysis</a:t>
-            </a:r>
-          </a:p>
-          <a:p>
-            <a:pPr marL="342900" indent="-342900">
-              <a:buFont typeface="Arial" panose="020B0604020202020204" pitchFamily="34" charset="0"/>
-              <a:buChar char="•"/>
-            </a:pPr>
-            <a:r>
-              <a:rPr lang="en-IN" sz="2300" b="1" dirty="0"/>
-              <a:t>Result:</a:t>
-            </a:r>
-            <a:r>
-              <a:rPr lang="en-IN" sz="2300" dirty="0"/>
-              <a:t> Higher accuracy than standard Mask R-CNN and Faster R-CNN</a:t>
-            </a:r>
-          </a:p>
-          <a:p>
-            <a:endParaRPr lang="en-IN" dirty="0"/>
-          </a:p>
-        </p:txBody>
-      </p:sp>
-    </p:spTree>
-    <p:extLst>
-      <p:ext uri="{BB962C8B-B14F-4D97-AF65-F5344CB8AC3E}">
-        <p14:creationId xmlns:p14="http://schemas.microsoft.com/office/powerpoint/2010/main" val="2357732677"/>
-      </p:ext>
-    </p:extLst>
-  </p:cSld>
-  <p:clrMapOvr>
-    <a:masterClrMapping/>
-  </p:clrMapOvr>
-</p:sld>
-</file>
-
-<file path=ppt/slides/slide9.xml><?xml version="1.0" encoding="utf-8"?>
-<p:sld xmlns:a="http://schemas.openxmlformats.org/drawingml/2006/main" xmlns:r="http://schemas.openxmlformats.org/officeDocument/2006/relationships" xmlns:p="http://schemas.openxmlformats.org/presentationml/2006/main">
-  <p:cSld>
-    <p:spTree>
-      <p:nvGrpSpPr>
-        <p:cNvPr id="1" name=""/>
-        <p:cNvGrpSpPr/>
-        <p:nvPr/>
-      </p:nvGrpSpPr>
-      <p:grpSpPr>
-        <a:xfrm>
-          <a:off x="0" y="0"/>
-          <a:ext cx="0" cy="0"/>
-          <a:chOff x="0" y="0"/>
-          <a:chExt cx="0" cy="0"/>
-        </a:xfrm>
-      </p:grpSpPr>
-      <p:sp>
-        <p:nvSpPr>
-          <p:cNvPr id="2" name="Title 1">
-            <a:extLst>
-              <a:ext uri="{FF2B5EF4-FFF2-40B4-BE49-F238E27FC236}">
-                <a16:creationId xmlns:a16="http://schemas.microsoft.com/office/drawing/2014/main" id="{023E351A-841C-0E23-D95C-C13DDF8C7CBF}"/>
-              </a:ext>
-            </a:extLst>
-          </p:cNvPr>
-          <p:cNvSpPr>
-            <a:spLocks noGrp="1"/>
-          </p:cNvSpPr>
-          <p:nvPr>
-            <p:ph type="title"/>
-          </p:nvPr>
-        </p:nvSpPr>
-        <p:spPr>
-          <a:xfrm>
-            <a:off x="0" y="-1"/>
-            <a:ext cx="6390968" cy="1170039"/>
-          </a:xfrm>
-        </p:spPr>
-        <p:txBody>
-          <a:bodyPr/>
-          <a:lstStyle/>
-          <a:p>
-            <a:pPr>
-              <a:lnSpc>
-                <a:spcPts val="2400"/>
-              </a:lnSpc>
-              <a:spcBef>
-                <a:spcPts val="2400"/>
-              </a:spcBef>
-              <a:spcAft>
-                <a:spcPts val="1200"/>
-              </a:spcAft>
-            </a:pPr>
-            <a:r>
-              <a:rPr lang="en-IN" b="1" dirty="0">
-                <a:solidFill>
-                  <a:srgbClr val="0F1115"/>
-                </a:solidFill>
-                <a:effectLst/>
-                <a:latin typeface="quote-cjk-patch"/>
-              </a:rPr>
-              <a:t>Dataset &amp; Preprocessing</a:t>
-            </a:r>
-            <a:br>
-              <a:rPr lang="en-IN" b="1" dirty="0">
-                <a:solidFill>
-                  <a:srgbClr val="0F1115"/>
-                </a:solidFill>
-                <a:effectLst/>
-                <a:latin typeface="quote-cjk-patch"/>
-              </a:rPr>
-            </a:br>
-            <a:endParaRPr lang="en-IN" dirty="0"/>
-          </a:p>
-        </p:txBody>
-      </p:sp>
-      <p:graphicFrame>
-        <p:nvGraphicFramePr>
-          <p:cNvPr id="11" name="Table 10">
-            <a:extLst>
-              <a:ext uri="{FF2B5EF4-FFF2-40B4-BE49-F238E27FC236}">
-                <a16:creationId xmlns:a16="http://schemas.microsoft.com/office/drawing/2014/main" id="{4EB8FBBE-B163-567D-EC06-BEAAC7A98C5A}"/>
-              </a:ext>
-            </a:extLst>
-          </p:cNvPr>
-          <p:cNvGraphicFramePr>
-            <a:graphicFrameLocks noGrp="1"/>
-          </p:cNvGraphicFramePr>
-          <p:nvPr>
-            <p:extLst>
-              <p:ext uri="{D42A27DB-BD31-4B8C-83A1-F6EECF244321}">
-                <p14:modId xmlns:p14="http://schemas.microsoft.com/office/powerpoint/2010/main" val="2149345640"/>
-              </p:ext>
-            </p:extLst>
-          </p:nvPr>
-        </p:nvGraphicFramePr>
-        <p:xfrm>
-          <a:off x="381490" y="1839313"/>
-          <a:ext cx="5861994" cy="2693357"/>
-        </p:xfrm>
-        <a:graphic>
-          <a:graphicData uri="http://schemas.openxmlformats.org/drawingml/2006/table">
-            <a:tbl>
-              <a:tblPr/>
-              <a:tblGrid>
-                <a:gridCol w="2930997">
-                  <a:extLst>
-                    <a:ext uri="{9D8B030D-6E8A-4147-A177-3AD203B41FA5}">
-                      <a16:colId xmlns:a16="http://schemas.microsoft.com/office/drawing/2014/main" val="1211643700"/>
-                    </a:ext>
-                  </a:extLst>
-                </a:gridCol>
-                <a:gridCol w="2930997">
-                  <a:extLst>
-                    <a:ext uri="{9D8B030D-6E8A-4147-A177-3AD203B41FA5}">
-                      <a16:colId xmlns:a16="http://schemas.microsoft.com/office/drawing/2014/main" val="1141460696"/>
-                    </a:ext>
-                  </a:extLst>
-                </a:gridCol>
-              </a:tblGrid>
-              <a:tr h="407288">
-                <a:tc>
-                  <a:txBody>
-                    <a:bodyPr/>
-                    <a:lstStyle/>
-                    <a:p>
-                      <a:pPr algn="l">
-                        <a:lnSpc>
-                          <a:spcPts val="1875"/>
-                        </a:lnSpc>
-                        <a:buNone/>
-                      </a:pPr>
-                      <a:r>
-                        <a:rPr lang="en-IN" b="0">
-                          <a:effectLst/>
-                          <a:latin typeface="quote-cjk-patch"/>
-                        </a:rPr>
-                        <a:t>Parameter</a:t>
-                      </a:r>
-                    </a:p>
-                  </a:txBody>
-                  <a:tcPr marR="121920" marT="76200" marB="76200" anchor="ctr">
-                    <a:lnL>
-                      <a:noFill/>
-                    </a:lnL>
-                    <a:lnR>
-                      <a:noFill/>
-                    </a:lnR>
-                    <a:lnT>
-                      <a:noFill/>
-                    </a:lnT>
-                    <a:lnB>
-                      <a:noFill/>
-                    </a:lnB>
-                    <a:noFill/>
-                  </a:tcPr>
-                </a:tc>
-                <a:tc>
-                  <a:txBody>
-                    <a:bodyPr/>
-                    <a:lstStyle/>
-                    <a:p>
-                      <a:pPr algn="l">
-                        <a:lnSpc>
-                          <a:spcPts val="1875"/>
-                        </a:lnSpc>
-                        <a:buNone/>
-                      </a:pPr>
-                      <a:r>
-                        <a:rPr lang="en-IN" b="0">
-                          <a:effectLst/>
-                          <a:latin typeface="quote-cjk-patch"/>
-                        </a:rPr>
-                        <a:t>Value</a:t>
-                      </a:r>
-                    </a:p>
-                  </a:txBody>
-                  <a:tcPr marL="121920" marR="121920" marT="76200" marB="76200" anchor="ctr">
-                    <a:lnL>
-                      <a:noFill/>
-                    </a:lnL>
-                    <a:lnR>
-                      <a:noFill/>
-                    </a:lnR>
-                    <a:lnT>
-                      <a:noFill/>
-                    </a:lnT>
-                    <a:lnB>
-                      <a:noFill/>
-                    </a:lnB>
-                    <a:noFill/>
-                  </a:tcPr>
-                </a:tc>
-                <a:extLst>
-                  <a:ext uri="{0D108BD9-81ED-4DB2-BD59-A6C34878D82A}">
-                    <a16:rowId xmlns:a16="http://schemas.microsoft.com/office/drawing/2014/main" val="1058154417"/>
-                  </a:ext>
-                </a:extLst>
-              </a:tr>
-              <a:tr h="407288">
-                <a:tc>
-                  <a:txBody>
-                    <a:bodyPr/>
-                    <a:lstStyle/>
-                    <a:p>
-                      <a:pPr>
-                        <a:lnSpc>
-                          <a:spcPts val="1875"/>
-                        </a:lnSpc>
-                        <a:buNone/>
-                      </a:pPr>
-                      <a:r>
-                        <a:rPr lang="en-IN" b="0" dirty="0">
-                          <a:effectLst/>
-                          <a:latin typeface="quote-cjk-patch"/>
-                        </a:rPr>
-                        <a:t>Total Images</a:t>
-                      </a:r>
-                    </a:p>
-                  </a:txBody>
-                  <a:tcPr marR="121920" marT="76200" marB="76200" anchor="ctr">
-                    <a:lnL>
-                      <a:noFill/>
-                    </a:lnL>
-                    <a:lnR>
-                      <a:noFill/>
-                    </a:lnR>
-                    <a:lnT>
-                      <a:noFill/>
-                    </a:lnT>
-                    <a:lnB>
-                      <a:noFill/>
-                    </a:lnB>
-                    <a:noFill/>
-                  </a:tcPr>
-                </a:tc>
-                <a:tc>
-                  <a:txBody>
-                    <a:bodyPr/>
-                    <a:lstStyle/>
-                    <a:p>
-                      <a:pPr>
-                        <a:lnSpc>
-                          <a:spcPts val="1875"/>
-                        </a:lnSpc>
-                        <a:buNone/>
-                      </a:pPr>
-                      <a:r>
-                        <a:rPr lang="en-IN" b="0">
-                          <a:effectLst/>
-                          <a:latin typeface="quote-cjk-patch"/>
-                        </a:rPr>
-                        <a:t>6,480</a:t>
-                      </a:r>
-                    </a:p>
-                  </a:txBody>
-                  <a:tcPr marL="121920" marT="76200" marB="76200" anchor="ctr">
-                    <a:lnL>
-                      <a:noFill/>
-                    </a:lnL>
-                    <a:lnR>
-                      <a:noFill/>
-                    </a:lnR>
-                    <a:lnT>
-                      <a:noFill/>
-                    </a:lnT>
-                    <a:lnB>
-                      <a:noFill/>
-                    </a:lnB>
-                    <a:noFill/>
-                  </a:tcPr>
-                </a:tc>
-                <a:extLst>
-                  <a:ext uri="{0D108BD9-81ED-4DB2-BD59-A6C34878D82A}">
-                    <a16:rowId xmlns:a16="http://schemas.microsoft.com/office/drawing/2014/main" val="2287787102"/>
-                  </a:ext>
-                </a:extLst>
-              </a:tr>
-              <a:tr h="407288">
-                <a:tc>
-                  <a:txBody>
-                    <a:bodyPr/>
-                    <a:lstStyle/>
-                    <a:p>
-                      <a:pPr>
-                        <a:lnSpc>
-                          <a:spcPts val="1875"/>
-                        </a:lnSpc>
-                        <a:buNone/>
-                      </a:pPr>
-                      <a:r>
-                        <a:rPr lang="en-IN" b="0">
-                          <a:effectLst/>
-                          <a:latin typeface="quote-cjk-patch"/>
-                        </a:rPr>
-                        <a:t>Total Traffic Sign Instances</a:t>
-                      </a:r>
-                    </a:p>
-                  </a:txBody>
-                  <a:tcPr marR="121920" marT="76200" marB="76200" anchor="ctr">
-                    <a:lnL>
-                      <a:noFill/>
-                    </a:lnL>
-                    <a:lnR>
-                      <a:noFill/>
-                    </a:lnR>
-                    <a:lnT>
-                      <a:noFill/>
-                    </a:lnT>
-                    <a:lnB>
-                      <a:noFill/>
-                    </a:lnB>
-                    <a:noFill/>
-                  </a:tcPr>
-                </a:tc>
-                <a:tc>
-                  <a:txBody>
-                    <a:bodyPr/>
-                    <a:lstStyle/>
-                    <a:p>
-                      <a:pPr>
-                        <a:lnSpc>
-                          <a:spcPts val="1875"/>
-                        </a:lnSpc>
-                        <a:buNone/>
-                      </a:pPr>
-                      <a:r>
-                        <a:rPr lang="en-IN" b="0">
-                          <a:effectLst/>
-                          <a:latin typeface="quote-cjk-patch"/>
-                        </a:rPr>
-                        <a:t>7,056</a:t>
-                      </a:r>
-                    </a:p>
-                  </a:txBody>
-                  <a:tcPr marL="121920" marT="76200" marB="76200" anchor="ctr">
-                    <a:lnL>
-                      <a:noFill/>
-                    </a:lnL>
-                    <a:lnR>
-                      <a:noFill/>
-                    </a:lnR>
-                    <a:lnT>
-                      <a:noFill/>
-                    </a:lnT>
-                    <a:lnB>
-                      <a:noFill/>
-                    </a:lnB>
-                    <a:noFill/>
-                  </a:tcPr>
-                </a:tc>
-                <a:extLst>
-                  <a:ext uri="{0D108BD9-81ED-4DB2-BD59-A6C34878D82A}">
-                    <a16:rowId xmlns:a16="http://schemas.microsoft.com/office/drawing/2014/main" val="3285033943"/>
-                  </a:ext>
-                </a:extLst>
-              </a:tr>
-              <a:tr h="407288">
-                <a:tc>
-                  <a:txBody>
-                    <a:bodyPr/>
-                    <a:lstStyle/>
-                    <a:p>
-                      <a:pPr>
-                        <a:lnSpc>
-                          <a:spcPts val="1875"/>
-                        </a:lnSpc>
-                        <a:buNone/>
-                      </a:pPr>
-                      <a:r>
-                        <a:rPr lang="en-IN" b="0" dirty="0">
-                          <a:effectLst/>
-                          <a:latin typeface="quote-cjk-patch"/>
-                        </a:rPr>
-                        <a:t>Categories (Indian signs)</a:t>
-                      </a:r>
-                    </a:p>
-                  </a:txBody>
-                  <a:tcPr marR="121920" marT="76200" marB="76200" anchor="ctr">
-                    <a:lnL>
-                      <a:noFill/>
-                    </a:lnL>
-                    <a:lnR>
-                      <a:noFill/>
-                    </a:lnR>
-                    <a:lnT>
-                      <a:noFill/>
-                    </a:lnT>
-                    <a:lnB>
-                      <a:noFill/>
-                    </a:lnB>
-                    <a:noFill/>
-                  </a:tcPr>
-                </a:tc>
-                <a:tc>
-                  <a:txBody>
-                    <a:bodyPr/>
-                    <a:lstStyle/>
-                    <a:p>
-                      <a:pPr>
-                        <a:lnSpc>
-                          <a:spcPts val="1875"/>
-                        </a:lnSpc>
-                        <a:buNone/>
-                      </a:pPr>
-                      <a:r>
-                        <a:rPr lang="en-IN" b="0">
-                          <a:effectLst/>
-                          <a:latin typeface="quote-cjk-patch"/>
-                        </a:rPr>
-                        <a:t>87</a:t>
-                      </a:r>
-                    </a:p>
-                  </a:txBody>
-                  <a:tcPr marL="121920" marT="76200" marB="76200" anchor="ctr">
-                    <a:lnL>
-                      <a:noFill/>
-                    </a:lnL>
-                    <a:lnR>
-                      <a:noFill/>
-                    </a:lnR>
-                    <a:lnT>
-                      <a:noFill/>
-                    </a:lnT>
-                    <a:lnB>
-                      <a:noFill/>
-                    </a:lnB>
-                    <a:noFill/>
-                  </a:tcPr>
-                </a:tc>
-                <a:extLst>
-                  <a:ext uri="{0D108BD9-81ED-4DB2-BD59-A6C34878D82A}">
-                    <a16:rowId xmlns:a16="http://schemas.microsoft.com/office/drawing/2014/main" val="3166671730"/>
-                  </a:ext>
-                </a:extLst>
-              </a:tr>
-              <a:tr h="656917">
-                <a:tc>
-                  <a:txBody>
-                    <a:bodyPr/>
-                    <a:lstStyle/>
-                    <a:p>
-                      <a:pPr>
-                        <a:lnSpc>
-                          <a:spcPts val="1875"/>
-                        </a:lnSpc>
-                        <a:buNone/>
-                      </a:pPr>
-                      <a:r>
-                        <a:rPr lang="en-IN" b="0">
-                          <a:effectLst/>
-                          <a:latin typeface="quote-cjk-patch"/>
-                        </a:rPr>
-                        <a:t>Categories (from standard datasets)</a:t>
-                      </a:r>
-                    </a:p>
-                  </a:txBody>
-                  <a:tcPr marR="121920" marT="76200" marB="76200" anchor="ctr">
-                    <a:lnL>
-                      <a:noFill/>
-                    </a:lnL>
-                    <a:lnR>
-                      <a:noFill/>
-                    </a:lnR>
-                    <a:lnT>
-                      <a:noFill/>
-                    </a:lnT>
-                    <a:lnB>
-                      <a:noFill/>
-                    </a:lnB>
-                    <a:noFill/>
-                  </a:tcPr>
-                </a:tc>
-                <a:tc>
-                  <a:txBody>
-                    <a:bodyPr/>
-                    <a:lstStyle/>
-                    <a:p>
-                      <a:pPr>
-                        <a:lnSpc>
-                          <a:spcPts val="1875"/>
-                        </a:lnSpc>
-                        <a:buNone/>
-                      </a:pPr>
-                      <a:r>
-                        <a:rPr lang="en-IN" b="0">
-                          <a:effectLst/>
-                          <a:latin typeface="quote-cjk-patch"/>
-                        </a:rPr>
-                        <a:t>13</a:t>
-                      </a:r>
-                    </a:p>
-                  </a:txBody>
-                  <a:tcPr marL="121920" marT="76200" marB="76200" anchor="ctr">
-                    <a:lnL>
-                      <a:noFill/>
-                    </a:lnL>
-                    <a:lnR>
-                      <a:noFill/>
-                    </a:lnR>
-                    <a:lnT>
-                      <a:noFill/>
-                    </a:lnT>
-                    <a:lnB>
-                      <a:noFill/>
-                    </a:lnB>
-                    <a:noFill/>
-                  </a:tcPr>
-                </a:tc>
-                <a:extLst>
-                  <a:ext uri="{0D108BD9-81ED-4DB2-BD59-A6C34878D82A}">
-                    <a16:rowId xmlns:a16="http://schemas.microsoft.com/office/drawing/2014/main" val="123367131"/>
-                  </a:ext>
-                </a:extLst>
-              </a:tr>
-              <a:tr h="407288">
-                <a:tc>
-                  <a:txBody>
-                    <a:bodyPr/>
-                    <a:lstStyle/>
-                    <a:p>
-                      <a:pPr>
-                        <a:lnSpc>
-                          <a:spcPts val="1875"/>
-                        </a:lnSpc>
-                        <a:buNone/>
-                      </a:pPr>
-                      <a:r>
-                        <a:rPr lang="en-IN" b="1">
-                          <a:effectLst/>
-                          <a:latin typeface="quote-cjk-patch"/>
-                        </a:rPr>
-                        <a:t>Total Categories</a:t>
-                      </a:r>
-                      <a:endParaRPr lang="en-IN" b="0">
-                        <a:effectLst/>
-                        <a:latin typeface="quote-cjk-patch"/>
-                      </a:endParaRPr>
-                    </a:p>
-                  </a:txBody>
-                  <a:tcPr marR="121920" marT="76200" marB="76200" anchor="ctr">
-                    <a:lnL>
-                      <a:noFill/>
-                    </a:lnL>
-                    <a:lnR>
-                      <a:noFill/>
-                    </a:lnR>
-                    <a:lnT>
-                      <a:noFill/>
-                    </a:lnT>
-                    <a:lnB>
-                      <a:noFill/>
-                    </a:lnB>
-                    <a:noFill/>
-                  </a:tcPr>
-                </a:tc>
-                <a:tc>
-                  <a:txBody>
-                    <a:bodyPr/>
-                    <a:lstStyle/>
-                    <a:p>
-                      <a:pPr>
-                        <a:lnSpc>
-                          <a:spcPts val="1875"/>
-                        </a:lnSpc>
-                        <a:buNone/>
-                      </a:pPr>
-                      <a:r>
-                        <a:rPr lang="en-IN" b="1" dirty="0">
-                          <a:effectLst/>
-                          <a:latin typeface="quote-cjk-patch"/>
-                        </a:rPr>
-                        <a:t>100</a:t>
-                      </a:r>
-                      <a:endParaRPr lang="en-IN" b="0" dirty="0">
-                        <a:effectLst/>
-                        <a:latin typeface="quote-cjk-patch"/>
-                      </a:endParaRPr>
-                    </a:p>
-                  </a:txBody>
-                  <a:tcPr marL="121920" marT="76200" marB="76200" anchor="ctr">
-                    <a:lnL>
-                      <a:noFill/>
-                    </a:lnL>
-                    <a:lnR>
-                      <a:noFill/>
-                    </a:lnR>
-                    <a:lnT>
-                      <a:noFill/>
-                    </a:lnT>
-                    <a:lnB>
-                      <a:noFill/>
-                    </a:lnB>
-                    <a:noFill/>
-                  </a:tcPr>
-                </a:tc>
-                <a:extLst>
-                  <a:ext uri="{0D108BD9-81ED-4DB2-BD59-A6C34878D82A}">
-                    <a16:rowId xmlns:a16="http://schemas.microsoft.com/office/drawing/2014/main" val="2477501240"/>
-                  </a:ext>
-                </a:extLst>
-              </a:tr>
-            </a:tbl>
-          </a:graphicData>
-        </a:graphic>
-      </p:graphicFrame>
-      <p:sp>
-        <p:nvSpPr>
-          <p:cNvPr id="12" name="Rectangle 5">
-            <a:extLst>
-              <a:ext uri="{FF2B5EF4-FFF2-40B4-BE49-F238E27FC236}">
-                <a16:creationId xmlns:a16="http://schemas.microsoft.com/office/drawing/2014/main" id="{AE8D7373-CDB3-2EED-D3D9-1C7D1768C0AF}"/>
-              </a:ext>
-            </a:extLst>
-          </p:cNvPr>
-          <p:cNvSpPr>
-            <a:spLocks noGrp="1" noChangeArrowheads="1"/>
-          </p:cNvSpPr>
-          <p:nvPr>
-            <p:ph type="body"/>
-          </p:nvPr>
-        </p:nvSpPr>
-        <p:spPr bwMode="auto">
-          <a:xfrm>
-            <a:off x="1" y="856339"/>
-            <a:ext cx="8927690" cy="1107996"/>
-          </a:xfrm>
-          <a:prstGeom prst="rect">
-            <a:avLst/>
-          </a:prstGeom>
-          <a:solidFill>
-            <a:srgbClr val="FFFFFF"/>
-          </a:solidFill>
-          <a:ln>
-            <a:noFill/>
-          </a:ln>
-          <a:effectLst/>
-          <a:extLst>
-            <a:ext uri="{91240B29-F687-4F45-9708-019B960494DF}">
-              <a14:hiddenLine xmlns:a14="http://schemas.microsoft.com/office/drawing/2010/main" w="9525">
-                <a:solidFill>
-                  <a:schemeClr val="tx1"/>
-                </a:solidFill>
-                <a:miter lim="800000"/>
-                <a:headEnd/>
-                <a:tailEnd/>
-              </a14:hiddenLine>
-            </a:ext>
-            <a:ext uri="{AF507438-7753-43E0-B8FC-AC1667EBCBE1}">
-              <a14:hiddenEffects xmlns:a14="http://schemas.microsoft.com/office/drawing/2010/main">
-                <a:effectLst>
-                  <a:outerShdw dist="35921" dir="2700000" algn="ctr" rotWithShape="0">
-                    <a:schemeClr val="bg2"/>
-                  </a:outerShdw>
-                </a:effectLst>
-              </a14:hiddenEffects>
-            </a:ext>
-          </a:extLst>
-        </p:spPr>
-        <p:txBody>
-          <a:bodyPr vert="horz" wrap="square" lIns="91440" tIns="45720" rIns="91440" bIns="45720" numCol="1" anchor="ctr" anchorCtr="0" compatLnSpc="1">
-            <a:prstTxWarp prst="textNoShape">
-              <a:avLst/>
-            </a:prstTxWarp>
-            <a:spAutoFit/>
-          </a:bodyPr>
-          <a:lstStyle>
-            <a:lvl1pPr eaLnBrk="0" fontAlgn="base" hangingPunct="0">
-              <a:spcBef>
-                <a:spcPct val="0"/>
-              </a:spcBef>
-              <a:spcAft>
-                <a:spcPct val="0"/>
-              </a:spcAft>
-              <a:defRPr>
-                <a:solidFill>
-                  <a:schemeClr val="tx1"/>
-                </a:solidFill>
-                <a:latin typeface="Arial" panose="020B0604020202020204" pitchFamily="34" charset="0"/>
-              </a:defRPr>
-            </a:lvl1pPr>
-            <a:lvl2pPr eaLnBrk="0" fontAlgn="base" hangingPunct="0">
-              <a:spcBef>
-                <a:spcPct val="0"/>
-              </a:spcBef>
-              <a:spcAft>
-                <a:spcPct val="0"/>
-              </a:spcAft>
-              <a:defRPr>
-                <a:solidFill>
-                  <a:schemeClr val="tx1"/>
-                </a:solidFill>
-                <a:latin typeface="Arial" panose="020B0604020202020204" pitchFamily="34" charset="0"/>
-              </a:defRPr>
-            </a:lvl2pPr>
-            <a:lvl3pPr eaLnBrk="0" fontAlgn="base" hangingPunct="0">
-              <a:spcBef>
-                <a:spcPct val="0"/>
-              </a:spcBef>
-              <a:spcAft>
-                <a:spcPct val="0"/>
-              </a:spcAft>
-              <a:defRPr>
-                <a:solidFill>
-                  <a:schemeClr val="tx1"/>
-                </a:solidFill>
-                <a:latin typeface="Arial" panose="020B0604020202020204" pitchFamily="34" charset="0"/>
-              </a:defRPr>
-            </a:lvl3pPr>
-            <a:lvl4pPr eaLnBrk="0" fontAlgn="base" hangingPunct="0">
-              <a:spcBef>
-                <a:spcPct val="0"/>
-              </a:spcBef>
-              <a:spcAft>
-                <a:spcPct val="0"/>
-              </a:spcAft>
-              <a:defRPr>
-                <a:solidFill>
-                  <a:schemeClr val="tx1"/>
-                </a:solidFill>
-                <a:latin typeface="Arial" panose="020B0604020202020204" pitchFamily="34" charset="0"/>
-              </a:defRPr>
-            </a:lvl4pPr>
-            <a:lvl5pPr eaLnBrk="0" fontAlgn="base" hangingPunct="0">
-              <a:spcBef>
-                <a:spcPct val="0"/>
-              </a:spcBef>
-              <a:spcAft>
-                <a:spcPct val="0"/>
-              </a:spcAft>
-              <a:defRPr>
-                <a:solidFill>
-                  <a:schemeClr val="tx1"/>
-                </a:solidFill>
-                <a:latin typeface="Arial" panose="020B0604020202020204" pitchFamily="34" charset="0"/>
-              </a:defRPr>
-            </a:lvl5pPr>
-            <a:lvl6pPr eaLnBrk="0" fontAlgn="base" hangingPunct="0">
-              <a:spcBef>
-                <a:spcPct val="0"/>
-              </a:spcBef>
-              <a:spcAft>
-                <a:spcPct val="0"/>
-              </a:spcAft>
-              <a:defRPr>
-                <a:solidFill>
-                  <a:schemeClr val="tx1"/>
-                </a:solidFill>
-                <a:latin typeface="Arial" panose="020B0604020202020204" pitchFamily="34" charset="0"/>
-              </a:defRPr>
-            </a:lvl6pPr>
-            <a:lvl7pPr eaLnBrk="0" fontAlgn="base" hangingPunct="0">
-              <a:spcBef>
-                <a:spcPct val="0"/>
-              </a:spcBef>
-              <a:spcAft>
-                <a:spcPct val="0"/>
-              </a:spcAft>
-              <a:defRPr>
-                <a:solidFill>
-                  <a:schemeClr val="tx1"/>
-                </a:solidFill>
-                <a:latin typeface="Arial" panose="020B0604020202020204" pitchFamily="34" charset="0"/>
-              </a:defRPr>
-            </a:lvl7pPr>
-            <a:lvl8pPr eaLnBrk="0" fontAlgn="base" hangingPunct="0">
-              <a:spcBef>
-                <a:spcPct val="0"/>
-              </a:spcBef>
-              <a:spcAft>
-                <a:spcPct val="0"/>
-              </a:spcAft>
-              <a:defRPr>
-                <a:solidFill>
-                  <a:schemeClr val="tx1"/>
-                </a:solidFill>
-                <a:latin typeface="Arial" panose="020B0604020202020204" pitchFamily="34" charset="0"/>
-              </a:defRPr>
-            </a:lvl8pPr>
-            <a:lvl9pPr eaLnBrk="0" fontAlgn="base" hangingPunct="0">
-              <a:spcBef>
-                <a:spcPct val="0"/>
-              </a:spcBef>
-              <a:spcAft>
-                <a:spcPct val="0"/>
-              </a:spcAft>
-              <a:defRPr>
-                <a:solidFill>
-                  <a:schemeClr val="tx1"/>
-                </a:solidFill>
-                <a:latin typeface="Arial" panose="020B0604020202020204" pitchFamily="34" charset="0"/>
-              </a:defRPr>
-            </a:lvl9pPr>
-          </a:lstStyle>
-          <a:p>
-            <a:pPr marL="0" marR="0" lvl="0" indent="0" algn="l" defTabSz="914400" rtl="0" eaLnBrk="0" fontAlgn="base" latinLnBrk="0" hangingPunct="0">
-              <a:lnSpc>
-                <a:spcPct val="100000"/>
-              </a:lnSpc>
-              <a:spcBef>
-                <a:spcPct val="0"/>
-              </a:spcBef>
-              <a:spcAft>
-                <a:spcPct val="0"/>
-              </a:spcAft>
-              <a:buClrTx/>
-              <a:buSzTx/>
-              <a:buFontTx/>
-              <a:buNone/>
-              <a:tabLst/>
-            </a:pPr>
-            <a:r>
-              <a:rPr kumimoji="0" lang="en-US" altLang="en-US" sz="2400" b="1" i="0" u="none" strike="noStrike" cap="none" normalizeH="0" baseline="0" dirty="0">
-                <a:ln>
-                  <a:noFill/>
-                </a:ln>
-                <a:solidFill>
-                  <a:srgbClr val="0F1115"/>
-                </a:solidFill>
-                <a:effectLst/>
-                <a:latin typeface="quote-cjk-patch"/>
-              </a:rPr>
-              <a:t>Custom Indian Traffic Sign Dataset</a:t>
-            </a:r>
-            <a:endParaRPr kumimoji="0" lang="en-US" altLang="en-US" sz="2400" b="0" i="0" u="none" strike="noStrike" cap="none" normalizeH="0" baseline="0" dirty="0">
-              <a:ln>
-                <a:noFill/>
-              </a:ln>
-              <a:solidFill>
-                <a:schemeClr val="tx1"/>
-              </a:solidFill>
-              <a:effectLst/>
-            </a:endParaRPr>
-          </a:p>
-          <a:p>
-            <a:pPr marL="0" marR="0" lvl="0" indent="0" algn="l" defTabSz="914400" rtl="0" eaLnBrk="0" fontAlgn="base" latinLnBrk="0" hangingPunct="0">
-              <a:lnSpc>
-                <a:spcPct val="100000"/>
-              </a:lnSpc>
-              <a:spcBef>
-                <a:spcPct val="0"/>
-              </a:spcBef>
-              <a:spcAft>
-                <a:spcPct val="0"/>
-              </a:spcAft>
-              <a:buClrTx/>
-              <a:buSzTx/>
-              <a:buFontTx/>
-              <a:buNone/>
-              <a:tabLst/>
-            </a:pPr>
-            <a:r>
-              <a:rPr kumimoji="0" lang="en-US" altLang="en-US" sz="2400" b="1" i="0" u="none" strike="noStrike" cap="none" normalizeH="0" baseline="0" dirty="0">
-                <a:ln>
-                  <a:noFill/>
-                </a:ln>
-                <a:solidFill>
-                  <a:srgbClr val="0F1115"/>
-                </a:solidFill>
-                <a:effectLst/>
-                <a:latin typeface="quote-cjk-patch"/>
-              </a:rPr>
-              <a:t>Dataset Statistics:</a:t>
-            </a:r>
-            <a:endParaRPr kumimoji="0" lang="en-US" altLang="en-US" sz="2400" b="0" i="0" u="none" strike="noStrike" cap="none" normalizeH="0" baseline="0" dirty="0">
-              <a:ln>
-                <a:noFill/>
-              </a:ln>
-              <a:solidFill>
-                <a:schemeClr val="tx1"/>
-              </a:solidFill>
-              <a:effectLst/>
-            </a:endParaRPr>
-          </a:p>
-          <a:p>
-            <a:pPr marL="0" marR="0" lvl="0" indent="0" algn="l" defTabSz="914400" rtl="0" eaLnBrk="0" fontAlgn="base" latinLnBrk="0" hangingPunct="0">
-              <a:lnSpc>
-                <a:spcPct val="100000"/>
-              </a:lnSpc>
-              <a:spcBef>
-                <a:spcPct val="0"/>
-              </a:spcBef>
-              <a:spcAft>
-                <a:spcPct val="0"/>
-              </a:spcAft>
-              <a:buClrTx/>
-              <a:buSzTx/>
-              <a:buFontTx/>
-              <a:buNone/>
-              <a:tabLst/>
-            </a:pPr>
-            <a:endParaRPr kumimoji="0" lang="en-US" altLang="en-US" sz="1800" b="0" i="0" u="none" strike="noStrike" cap="none" normalizeH="0" baseline="0" dirty="0">
-              <a:ln>
-                <a:noFill/>
-              </a:ln>
-              <a:solidFill>
-                <a:schemeClr val="tx1"/>
-              </a:solidFill>
-              <a:effectLst/>
-              <a:latin typeface="Arial" panose="020B0604020202020204" pitchFamily="34" charset="0"/>
-            </a:endParaRPr>
-          </a:p>
-        </p:txBody>
-      </p:sp>
-      <p:sp>
-        <p:nvSpPr>
-          <p:cNvPr id="13" name="TextBox 12">
-            <a:extLst>
-              <a:ext uri="{FF2B5EF4-FFF2-40B4-BE49-F238E27FC236}">
-                <a16:creationId xmlns:a16="http://schemas.microsoft.com/office/drawing/2014/main" id="{504039FA-F9DD-8A6A-1A7C-6E54BE28478C}"/>
-              </a:ext>
-            </a:extLst>
-          </p:cNvPr>
-          <p:cNvSpPr txBox="1"/>
-          <p:nvPr/>
-        </p:nvSpPr>
-        <p:spPr>
-          <a:xfrm>
-            <a:off x="216310" y="4801332"/>
-            <a:ext cx="8927690" cy="1292662"/>
-          </a:xfrm>
-          <a:prstGeom prst="rect">
-            <a:avLst/>
-          </a:prstGeom>
-          <a:noFill/>
-        </p:spPr>
-        <p:txBody>
-          <a:bodyPr wrap="square" rtlCol="0">
-            <a:spAutoFit/>
-          </a:bodyPr>
-          <a:lstStyle/>
-          <a:p>
-            <a:r>
-              <a:rPr lang="en-US" sz="2000" b="1" dirty="0"/>
-              <a:t>Data Sources:</a:t>
-            </a:r>
-            <a:endParaRPr lang="en-US" sz="2000" dirty="0"/>
-          </a:p>
-          <a:p>
-            <a:r>
-              <a:rPr lang="en-US" sz="2000" dirty="0"/>
-              <a:t>4,544 images (70.12%) — Real-world capture from Indian roads</a:t>
-            </a:r>
-          </a:p>
-          <a:p>
-            <a:r>
-              <a:rPr lang="en-US" sz="2000" dirty="0"/>
-              <a:t>1,936 images — Public websites (Jharkhand Police, India Mart, SlideShare</a:t>
-            </a:r>
-            <a:r>
-              <a:rPr lang="en-US" dirty="0"/>
-              <a:t>)</a:t>
-            </a:r>
-          </a:p>
-          <a:p>
-            <a:endParaRPr lang="en-IN" dirty="0"/>
-          </a:p>
-        </p:txBody>
-      </p:sp>
-    </p:spTree>
-    <p:extLst>
-      <p:ext uri="{BB962C8B-B14F-4D97-AF65-F5344CB8AC3E}">
-        <p14:creationId xmlns:p14="http://schemas.microsoft.com/office/powerpoint/2010/main" val="3131262716"/>
       </p:ext>
     </p:extLst>
   </p:cSld>
@@ -11241,12 +11657,6 @@
 </file>
 
 <file path=customXml/item1.xml><?xml version="1.0" encoding="utf-8"?>
-<p:properties xmlns:p="http://schemas.microsoft.com/office/2006/metadata/properties" xmlns:xsi="http://www.w3.org/2001/XMLSchema-instance" xmlns:pc="http://schemas.microsoft.com/office/infopath/2007/PartnerControls">
-  <documentManagement/>
-</p:properties>
-</file>
-
-<file path=customXml/item2.xml><?xml version="1.0" encoding="utf-8"?>
 <ct:contentTypeSchema xmlns:ct="http://schemas.microsoft.com/office/2006/metadata/contentType" xmlns:ma="http://schemas.microsoft.com/office/2006/metadata/properties/metaAttributes" ct:_="" ma:_="" ma:contentTypeName="Document" ma:contentTypeID="0x010100096F1BF43DDE004485E7A868D137D60A" ma:contentTypeVersion="0" ma:contentTypeDescription="Create a new document." ma:contentTypeScope="" ma:versionID="47fff7f98a9c49c088ba096c14cf4458">
   <xsd:schema xmlns:xsd="http://www.w3.org/2001/XMLSchema" xmlns:xs="http://www.w3.org/2001/XMLSchema" xmlns:p="http://schemas.microsoft.com/office/2006/metadata/properties" targetNamespace="http://schemas.microsoft.com/office/2006/metadata/properties" ma:root="true" ma:fieldsID="c05e9f2c4932a6a674126b9dde7716ea">
     <xsd:element name="properties">
@@ -11360,6 +11770,12 @@
 </ct:contentTypeSchema>
 </file>
 
+<file path=customXml/item2.xml><?xml version="1.0" encoding="utf-8"?>
+<p:properties xmlns:p="http://schemas.microsoft.com/office/2006/metadata/properties" xmlns:xsi="http://www.w3.org/2001/XMLSchema-instance" xmlns:pc="http://schemas.microsoft.com/office/infopath/2007/PartnerControls">
+  <documentManagement/>
+</p:properties>
+</file>
+
 <file path=customXml/item3.xml><?xml version="1.0" encoding="utf-8"?>
 <?mso-contentType ?>
 <FormTemplates xmlns="http://schemas.microsoft.com/sharepoint/v3/contenttype/forms">
@@ -11370,21 +11786,6 @@
 </file>
 
 <file path=customXml/itemProps1.xml><?xml version="1.0" encoding="utf-8"?>
-<ds:datastoreItem xmlns:ds="http://schemas.openxmlformats.org/officeDocument/2006/customXml" ds:itemID="{4A62A602-78C1-468C-BB25-57CD481DB741}">
-  <ds:schemaRefs>
-    <ds:schemaRef ds:uri="http://purl.org/dc/terms/"/>
-    <ds:schemaRef ds:uri="http://www.w3.org/XML/1998/namespace"/>
-    <ds:schemaRef ds:uri="http://purl.org/dc/dcmitype/"/>
-    <ds:schemaRef ds:uri="http://schemas.microsoft.com/office/2006/documentManagement/types"/>
-    <ds:schemaRef ds:uri="http://schemas.microsoft.com/office/2006/metadata/properties"/>
-    <ds:schemaRef ds:uri="http://purl.org/dc/elements/1.1/"/>
-    <ds:schemaRef ds:uri="http://schemas.microsoft.com/office/infopath/2007/PartnerControls"/>
-    <ds:schemaRef ds:uri="http://schemas.openxmlformats.org/package/2006/metadata/core-properties"/>
-  </ds:schemaRefs>
-</ds:datastoreItem>
-</file>
-
-<file path=customXml/itemProps2.xml><?xml version="1.0" encoding="utf-8"?>
 <ds:datastoreItem xmlns:ds="http://schemas.openxmlformats.org/officeDocument/2006/customXml" ds:itemID="{491DF113-39A2-46D5-BFDA-E63300A9ECAB}">
   <ds:schemaRefs>
     <ds:schemaRef ds:uri="http://schemas.microsoft.com/office/2006/metadata/contentType"/>
@@ -11400,6 +11801,21 @@
 </ds:datastoreItem>
 </file>
 
+<file path=customXml/itemProps2.xml><?xml version="1.0" encoding="utf-8"?>
+<ds:datastoreItem xmlns:ds="http://schemas.openxmlformats.org/officeDocument/2006/customXml" ds:itemID="{4A62A602-78C1-468C-BB25-57CD481DB741}">
+  <ds:schemaRefs>
+    <ds:schemaRef ds:uri="http://purl.org/dc/terms/"/>
+    <ds:schemaRef ds:uri="http://www.w3.org/XML/1998/namespace"/>
+    <ds:schemaRef ds:uri="http://purl.org/dc/dcmitype/"/>
+    <ds:schemaRef ds:uri="http://schemas.microsoft.com/office/2006/documentManagement/types"/>
+    <ds:schemaRef ds:uri="http://schemas.microsoft.com/office/2006/metadata/properties"/>
+    <ds:schemaRef ds:uri="http://purl.org/dc/elements/1.1/"/>
+    <ds:schemaRef ds:uri="http://schemas.microsoft.com/office/infopath/2007/PartnerControls"/>
+    <ds:schemaRef ds:uri="http://schemas.openxmlformats.org/package/2006/metadata/core-properties"/>
+  </ds:schemaRefs>
+</ds:datastoreItem>
+</file>
+
 <file path=customXml/itemProps3.xml><?xml version="1.0" encoding="utf-8"?>
 <ds:datastoreItem xmlns:ds="http://schemas.openxmlformats.org/officeDocument/2006/customXml" ds:itemID="{737ED6F0-5E4C-4CD0-9B68-9C53F925A6F7}">
   <ds:schemaRefs>

</xml_diff>